<commit_message>
Improve vocabulary pipeline reliability and media recovery
</commit_message>
<xml_diff>
--- a/templates/vocabulary_template_v3.pptx
+++ b/templates/vocabulary_template_v3.pptx
@@ -3224,8 +3224,8 @@
         </p:blipFill>
         <p:spPr>
           <a:xfrm>
-            <a:off x="540774" y="151320"/>
-            <a:ext cx="4178709" cy="3406118"/>
+            <a:off x="0" y="7061"/>
+            <a:ext cx="4719484" cy="3550377"/>
           </a:xfrm>
           <a:prstGeom prst="rect">
             <a:avLst/>
@@ -3326,7 +3326,7 @@
         </p:nvSpPr>
         <p:spPr>
           <a:xfrm>
-            <a:off x="4889704" y="2256576"/>
+            <a:off x="4889704" y="2457390"/>
             <a:ext cx="3806620" cy="1107996"/>
           </a:xfrm>
           <a:prstGeom prst="rect">
@@ -4092,12 +4092,105 @@
           </a:p>
         </p:txBody>
       </p:sp>
+      <p:sp>
+        <p:nvSpPr>
+          <p:cNvPr id="18" name="TextBox 17">
+            <a:extLst>
+              <a:ext uri="{FF2B5EF4-FFF2-40B4-BE49-F238E27FC236}">
+                <a16:creationId xmlns:a16="http://schemas.microsoft.com/office/drawing/2014/main" id="{D5CDFC0C-0262-8976-8D9D-643D44D1950F}"/>
+              </a:ext>
+            </a:extLst>
+          </p:cNvPr>
+          <p:cNvSpPr txBox="1"/>
+          <p:nvPr/>
+        </p:nvSpPr>
+        <p:spPr>
+          <a:xfrm>
+            <a:off x="8820449" y="2549723"/>
+            <a:ext cx="3412926" cy="923330"/>
+          </a:xfrm>
+          <a:prstGeom prst="rect">
+            <a:avLst/>
+          </a:prstGeom>
+          <a:noFill/>
+        </p:spPr>
+        <p:txBody>
+          <a:bodyPr wrap="square" lIns="0" tIns="0" rIns="0" bIns="0" anchor="t">
+            <a:spAutoFit/>
+          </a:bodyPr>
+          <a:lstStyle/>
+          <a:p>
+            <a:pPr algn="ctr"/>
+            <a:r>
+              <a:rPr lang="en-GB" sz="2000" b="1" dirty="0">
+                <a:solidFill>
+                  <a:srgbClr val="475569"/>
+                </a:solidFill>
+                <a:latin typeface="Noto Sans SemiBold"/>
+              </a:rPr>
+              <a:t>{{BASE_FORM}}</a:t>
+            </a:r>
+            <a:r>
+              <a:rPr sz="1600" b="1" dirty="0"/>
+              <a:t>
+</a:t>
+            </a:r>
+            <a:r>
+              <a:rPr sz="2000" b="1" dirty="0">
+                <a:solidFill>
+                  <a:srgbClr val="475569"/>
+                </a:solidFill>
+                <a:latin typeface="Noto Sans SemiBold"/>
+              </a:rPr>
+              <a:t> </a:t>
+            </a:r>
+            <a:r>
+              <a:rPr lang="en-GB" sz="2000" b="1" dirty="0">
+                <a:solidFill>
+                  <a:srgbClr val="475569"/>
+                </a:solidFill>
+                <a:latin typeface="Noto Sans SemiBold"/>
+              </a:rPr>
+              <a:t>{{PRESENT_FORM}}</a:t>
+            </a:r>
+            <a:r>
+              <a:rPr sz="1600" b="1" dirty="0"/>
+              <a:t>
+</a:t>
+            </a:r>
+            <a:r>
+              <a:rPr sz="2000" b="1" dirty="0">
+                <a:solidFill>
+                  <a:srgbClr val="475569"/>
+                </a:solidFill>
+                <a:latin typeface="Noto Sans SemiBold"/>
+              </a:rPr>
+              <a:t> </a:t>
+            </a:r>
+            <a:r>
+              <a:rPr lang="en-GB" sz="2000" b="1" dirty="0">
+                <a:solidFill>
+                  <a:srgbClr val="475569"/>
+                </a:solidFill>
+                <a:latin typeface="Noto Sans SemiBold"/>
+              </a:rPr>
+              <a:t>{{PAST_FORM}}</a:t>
+            </a:r>
+            <a:endParaRPr sz="2000" b="1" dirty="0">
+              <a:solidFill>
+                <a:srgbClr val="475569"/>
+              </a:solidFill>
+              <a:latin typeface="Noto Sans SemiBold"/>
+            </a:endParaRPr>
+          </a:p>
+        </p:txBody>
+      </p:sp>
       <p:pic>
         <p:nvPicPr>
-          <p:cNvPr id="16" name="VOCAB_IMAGE" descr="image.png">
+          <p:cNvPr id="9" name="VOCAB_IMAGE" descr="image.png">
             <a:extLst>
               <a:ext uri="{FF2B5EF4-FFF2-40B4-BE49-F238E27FC236}">
-                <a16:creationId xmlns:a16="http://schemas.microsoft.com/office/drawing/2014/main" id="{EB6F6498-06FD-CD32-84B5-AC82418A3BFC}"/>
+                <a16:creationId xmlns:a16="http://schemas.microsoft.com/office/drawing/2014/main" id="{368E1B53-F0B4-D894-E572-2A3C5253A9C7}"/>
               </a:ext>
             </a:extLst>
           </p:cNvPr>
@@ -4114,8 +4207,8 @@
         </p:blipFill>
         <p:spPr>
           <a:xfrm>
-            <a:off x="540774" y="151320"/>
-            <a:ext cx="4178709" cy="3406118"/>
+            <a:off x="0" y="7061"/>
+            <a:ext cx="4719484" cy="3550377"/>
           </a:xfrm>
           <a:prstGeom prst="rect">
             <a:avLst/>
@@ -4124,10 +4217,10 @@
       </p:pic>
       <p:sp>
         <p:nvSpPr>
-          <p:cNvPr id="18" name="TextBox 17">
+          <p:cNvPr id="12" name="TextBox 11">
             <a:extLst>
               <a:ext uri="{FF2B5EF4-FFF2-40B4-BE49-F238E27FC236}">
-                <a16:creationId xmlns:a16="http://schemas.microsoft.com/office/drawing/2014/main" id="{D5CDFC0C-0262-8976-8D9D-643D44D1950F}"/>
+                <a16:creationId xmlns:a16="http://schemas.microsoft.com/office/drawing/2014/main" id="{F75E7494-AA8E-47C6-92B3-0998CFE885EB}"/>
               </a:ext>
             </a:extLst>
           </p:cNvPr>
@@ -4136,100 +4229,7 @@
         </p:nvSpPr>
         <p:spPr>
           <a:xfrm>
-            <a:off x="8820449" y="2549723"/>
-            <a:ext cx="3412926" cy="923330"/>
-          </a:xfrm>
-          <a:prstGeom prst="rect">
-            <a:avLst/>
-          </a:prstGeom>
-          <a:noFill/>
-        </p:spPr>
-        <p:txBody>
-          <a:bodyPr wrap="square" lIns="0" tIns="0" rIns="0" bIns="0" anchor="t">
-            <a:spAutoFit/>
-          </a:bodyPr>
-          <a:lstStyle/>
-          <a:p>
-            <a:pPr algn="ctr"/>
-            <a:r>
-              <a:rPr lang="en-GB" sz="2000" b="1" dirty="0">
-                <a:solidFill>
-                  <a:srgbClr val="475569"/>
-                </a:solidFill>
-                <a:latin typeface="Noto Sans SemiBold"/>
-              </a:rPr>
-              <a:t>{{BASE_FORM}}</a:t>
-            </a:r>
-            <a:r>
-              <a:rPr sz="1600" b="1" dirty="0"/>
-              <a:t>
-</a:t>
-            </a:r>
-            <a:r>
-              <a:rPr sz="2000" b="1" dirty="0">
-                <a:solidFill>
-                  <a:srgbClr val="475569"/>
-                </a:solidFill>
-                <a:latin typeface="Noto Sans SemiBold"/>
-              </a:rPr>
-              <a:t> </a:t>
-            </a:r>
-            <a:r>
-              <a:rPr lang="en-GB" sz="2000" b="1" dirty="0">
-                <a:solidFill>
-                  <a:srgbClr val="475569"/>
-                </a:solidFill>
-                <a:latin typeface="Noto Sans SemiBold"/>
-              </a:rPr>
-              <a:t>{{PRESENT_FORM}}</a:t>
-            </a:r>
-            <a:r>
-              <a:rPr sz="1600" b="1" dirty="0"/>
-              <a:t>
-</a:t>
-            </a:r>
-            <a:r>
-              <a:rPr sz="2000" b="1" dirty="0">
-                <a:solidFill>
-                  <a:srgbClr val="475569"/>
-                </a:solidFill>
-                <a:latin typeface="Noto Sans SemiBold"/>
-              </a:rPr>
-              <a:t> </a:t>
-            </a:r>
-            <a:r>
-              <a:rPr lang="en-GB" sz="2000" b="1" dirty="0">
-                <a:solidFill>
-                  <a:srgbClr val="475569"/>
-                </a:solidFill>
-                <a:latin typeface="Noto Sans SemiBold"/>
-              </a:rPr>
-              <a:t>{{PAST_FORM}}</a:t>
-            </a:r>
-            <a:endParaRPr sz="2000" b="1" dirty="0">
-              <a:solidFill>
-                <a:srgbClr val="475569"/>
-              </a:solidFill>
-              <a:latin typeface="Noto Sans SemiBold"/>
-            </a:endParaRPr>
-          </a:p>
-        </p:txBody>
-      </p:sp>
-      <p:sp>
-        <p:nvSpPr>
-          <p:cNvPr id="22" name="TextBox 21">
-            <a:extLst>
-              <a:ext uri="{FF2B5EF4-FFF2-40B4-BE49-F238E27FC236}">
-                <a16:creationId xmlns:a16="http://schemas.microsoft.com/office/drawing/2014/main" id="{1F1235F0-AACD-CD45-0660-3233574E863F}"/>
-              </a:ext>
-            </a:extLst>
-          </p:cNvPr>
-          <p:cNvSpPr txBox="1"/>
-          <p:nvPr/>
-        </p:nvSpPr>
-        <p:spPr>
-          <a:xfrm>
-            <a:off x="4889704" y="2256576"/>
+            <a:off x="4889704" y="2457390"/>
             <a:ext cx="3806620" cy="1107996"/>
           </a:xfrm>
           <a:prstGeom prst="rect">
@@ -4638,7 +4638,7 @@
         </p:nvSpPr>
         <p:spPr>
           <a:xfrm>
-            <a:off x="2843902" y="5157522"/>
+            <a:off x="2630128" y="5247818"/>
             <a:ext cx="8774983" cy="369332"/>
           </a:xfrm>
           <a:prstGeom prst="rect">
@@ -4753,12 +4753,216 @@
           </a:p>
         </p:txBody>
       </p:sp>
+      <p:sp>
+        <p:nvSpPr>
+          <p:cNvPr id="19" name="TextBox 18">
+            <a:extLst>
+              <a:ext uri="{FF2B5EF4-FFF2-40B4-BE49-F238E27FC236}">
+                <a16:creationId xmlns:a16="http://schemas.microsoft.com/office/drawing/2014/main" id="{691F0482-326F-EE74-B18A-65FC3B640E92}"/>
+              </a:ext>
+            </a:extLst>
+          </p:cNvPr>
+          <p:cNvSpPr txBox="1"/>
+          <p:nvPr/>
+        </p:nvSpPr>
+        <p:spPr>
+          <a:xfrm>
+            <a:off x="8820449" y="2549723"/>
+            <a:ext cx="3412926" cy="923330"/>
+          </a:xfrm>
+          <a:prstGeom prst="rect">
+            <a:avLst/>
+          </a:prstGeom>
+          <a:noFill/>
+        </p:spPr>
+        <p:txBody>
+          <a:bodyPr wrap="square" lIns="0" tIns="0" rIns="0" bIns="0" anchor="t">
+            <a:spAutoFit/>
+          </a:bodyPr>
+          <a:lstStyle/>
+          <a:p>
+            <a:pPr algn="ctr"/>
+            <a:r>
+              <a:rPr lang="en-GB" sz="2000" b="1" dirty="0">
+                <a:solidFill>
+                  <a:srgbClr val="475569"/>
+                </a:solidFill>
+                <a:latin typeface="Noto Sans SemiBold"/>
+              </a:rPr>
+              <a:t>{{BASE_FORM}}</a:t>
+            </a:r>
+            <a:r>
+              <a:rPr sz="1600" b="1" dirty="0"/>
+              <a:t>
+</a:t>
+            </a:r>
+            <a:r>
+              <a:rPr sz="2000" b="1" dirty="0">
+                <a:solidFill>
+                  <a:srgbClr val="475569"/>
+                </a:solidFill>
+                <a:latin typeface="Noto Sans SemiBold"/>
+              </a:rPr>
+              <a:t> </a:t>
+            </a:r>
+            <a:r>
+              <a:rPr lang="en-GB" sz="2000" b="1" dirty="0">
+                <a:solidFill>
+                  <a:srgbClr val="475569"/>
+                </a:solidFill>
+                <a:latin typeface="Noto Sans SemiBold"/>
+              </a:rPr>
+              <a:t>{{PRESENT_FORM}}</a:t>
+            </a:r>
+            <a:r>
+              <a:rPr sz="1600" b="1" dirty="0"/>
+              <a:t>
+</a:t>
+            </a:r>
+            <a:r>
+              <a:rPr sz="2000" b="1" dirty="0">
+                <a:solidFill>
+                  <a:srgbClr val="475569"/>
+                </a:solidFill>
+                <a:latin typeface="Noto Sans SemiBold"/>
+              </a:rPr>
+              <a:t> </a:t>
+            </a:r>
+            <a:r>
+              <a:rPr lang="en-GB" sz="2000" b="1" dirty="0">
+                <a:solidFill>
+                  <a:srgbClr val="475569"/>
+                </a:solidFill>
+                <a:latin typeface="Noto Sans SemiBold"/>
+              </a:rPr>
+              <a:t>{{PAST_FORM}}</a:t>
+            </a:r>
+            <a:endParaRPr sz="2000" b="1" dirty="0">
+              <a:solidFill>
+                <a:srgbClr val="475569"/>
+              </a:solidFill>
+              <a:latin typeface="Noto Sans SemiBold"/>
+            </a:endParaRPr>
+          </a:p>
+        </p:txBody>
+      </p:sp>
+      <p:sp>
+        <p:nvSpPr>
+          <p:cNvPr id="23" name="TextBox 22">
+            <a:extLst>
+              <a:ext uri="{FF2B5EF4-FFF2-40B4-BE49-F238E27FC236}">
+                <a16:creationId xmlns:a16="http://schemas.microsoft.com/office/drawing/2014/main" id="{65D623EB-2A7F-7E13-A27F-15A5483F3E36}"/>
+              </a:ext>
+            </a:extLst>
+          </p:cNvPr>
+          <p:cNvSpPr txBox="1"/>
+          <p:nvPr/>
+        </p:nvSpPr>
+        <p:spPr>
+          <a:xfrm>
+            <a:off x="2630128" y="4432329"/>
+            <a:ext cx="9202532" cy="369332"/>
+          </a:xfrm>
+          <a:prstGeom prst="rect">
+            <a:avLst/>
+          </a:prstGeom>
+          <a:noFill/>
+        </p:spPr>
+        <p:txBody>
+          <a:bodyPr wrap="square" lIns="0" tIns="0" rIns="0" bIns="0" anchor="t">
+            <a:spAutoFit/>
+          </a:bodyPr>
+          <a:lstStyle/>
+          <a:p>
+            <a:r>
+              <a:rPr lang="en-GB" sz="2400" b="0" i="0" u="none" dirty="0">
+                <a:solidFill>
+                  <a:srgbClr val="2A3644"/>
+                </a:solidFill>
+                <a:latin typeface="Poppins ExtraBold"/>
+              </a:rPr>
+              <a:t>{{PAST_SENTENCE}}</a:t>
+            </a:r>
+            <a:endParaRPr sz="2400" b="0" i="0" u="none" dirty="0">
+              <a:solidFill>
+                <a:srgbClr val="2A3644"/>
+              </a:solidFill>
+              <a:latin typeface="Poppins ExtraBold"/>
+            </a:endParaRPr>
+          </a:p>
+        </p:txBody>
+      </p:sp>
+      <p:sp>
+        <p:nvSpPr>
+          <p:cNvPr id="25" name="TextBox 24">
+            <a:extLst>
+              <a:ext uri="{FF2B5EF4-FFF2-40B4-BE49-F238E27FC236}">
+                <a16:creationId xmlns:a16="http://schemas.microsoft.com/office/drawing/2014/main" id="{4D793BF9-6668-B68C-6469-0785C86AA080}"/>
+              </a:ext>
+            </a:extLst>
+          </p:cNvPr>
+          <p:cNvSpPr txBox="1"/>
+          <p:nvPr/>
+        </p:nvSpPr>
+        <p:spPr>
+          <a:xfrm>
+            <a:off x="7277098" y="1425516"/>
+            <a:ext cx="2838451" cy="253916"/>
+          </a:xfrm>
+          <a:prstGeom prst="rect">
+            <a:avLst/>
+          </a:prstGeom>
+          <a:noFill/>
+        </p:spPr>
+        <p:txBody>
+          <a:bodyPr wrap="square" lIns="0" tIns="0" rIns="0" bIns="0" anchor="ctr">
+            <a:spAutoFit/>
+          </a:bodyPr>
+          <a:lstStyle/>
+          <a:p>
+            <a:pPr algn="ctr"/>
+            <a:r>
+              <a:rPr lang="en-GB" sz="1650" u="none" dirty="0">
+                <a:solidFill>
+                  <a:srgbClr val="472D33"/>
+                </a:solidFill>
+                <a:latin typeface="Poppins ExtraBold"/>
+              </a:rPr>
+              <a:t>{{</a:t>
+            </a:r>
+            <a:r>
+              <a:rPr lang="en-GB" sz="1400" dirty="0">
+                <a:solidFill>
+                  <a:srgbClr val="472D33"/>
+                </a:solidFill>
+                <a:latin typeface="Poppins ExtraBold"/>
+              </a:rPr>
+              <a:t>PRONUNCIATION</a:t>
+            </a:r>
+            <a:r>
+              <a:rPr lang="en-GB" sz="1650" u="none" dirty="0">
+                <a:solidFill>
+                  <a:srgbClr val="472D33"/>
+                </a:solidFill>
+                <a:latin typeface="Poppins ExtraBold"/>
+              </a:rPr>
+              <a:t>}}</a:t>
+            </a:r>
+            <a:endParaRPr sz="1650" u="none" dirty="0">
+              <a:solidFill>
+                <a:srgbClr val="472D33"/>
+              </a:solidFill>
+              <a:latin typeface="Poppins ExtraBold"/>
+            </a:endParaRPr>
+          </a:p>
+        </p:txBody>
+      </p:sp>
       <p:pic>
         <p:nvPicPr>
-          <p:cNvPr id="17" name="VOCAB_IMAGE" descr="image.png">
+          <p:cNvPr id="4" name="VOCAB_IMAGE" descr="image.png">
             <a:extLst>
               <a:ext uri="{FF2B5EF4-FFF2-40B4-BE49-F238E27FC236}">
-                <a16:creationId xmlns:a16="http://schemas.microsoft.com/office/drawing/2014/main" id="{DED14AEE-B905-1667-0F2E-3B34BF006093}"/>
+                <a16:creationId xmlns:a16="http://schemas.microsoft.com/office/drawing/2014/main" id="{072C435A-3623-DF6A-1168-7B92D2916A18}"/>
               </a:ext>
             </a:extLst>
           </p:cNvPr>
@@ -4775,8 +4979,8 @@
         </p:blipFill>
         <p:spPr>
           <a:xfrm>
-            <a:off x="540774" y="151320"/>
-            <a:ext cx="4178709" cy="3406118"/>
+            <a:off x="0" y="7061"/>
+            <a:ext cx="4719484" cy="3550377"/>
           </a:xfrm>
           <a:prstGeom prst="rect">
             <a:avLst/>
@@ -4785,10 +4989,10 @@
       </p:pic>
       <p:sp>
         <p:nvSpPr>
-          <p:cNvPr id="19" name="TextBox 18">
+          <p:cNvPr id="9" name="TextBox 8">
             <a:extLst>
               <a:ext uri="{FF2B5EF4-FFF2-40B4-BE49-F238E27FC236}">
-                <a16:creationId xmlns:a16="http://schemas.microsoft.com/office/drawing/2014/main" id="{691F0482-326F-EE74-B18A-65FC3B640E92}"/>
+                <a16:creationId xmlns:a16="http://schemas.microsoft.com/office/drawing/2014/main" id="{42C33F70-C76D-DCCC-A106-5AB88D4753B0}"/>
               </a:ext>
             </a:extLst>
           </p:cNvPr>
@@ -4797,100 +5001,7 @@
         </p:nvSpPr>
         <p:spPr>
           <a:xfrm>
-            <a:off x="8820449" y="2549723"/>
-            <a:ext cx="3412926" cy="923330"/>
-          </a:xfrm>
-          <a:prstGeom prst="rect">
-            <a:avLst/>
-          </a:prstGeom>
-          <a:noFill/>
-        </p:spPr>
-        <p:txBody>
-          <a:bodyPr wrap="square" lIns="0" tIns="0" rIns="0" bIns="0" anchor="t">
-            <a:spAutoFit/>
-          </a:bodyPr>
-          <a:lstStyle/>
-          <a:p>
-            <a:pPr algn="ctr"/>
-            <a:r>
-              <a:rPr lang="en-GB" sz="2000" b="1" dirty="0">
-                <a:solidFill>
-                  <a:srgbClr val="475569"/>
-                </a:solidFill>
-                <a:latin typeface="Noto Sans SemiBold"/>
-              </a:rPr>
-              <a:t>{{BASE_FORM}}</a:t>
-            </a:r>
-            <a:r>
-              <a:rPr sz="1600" b="1" dirty="0"/>
-              <a:t>
-</a:t>
-            </a:r>
-            <a:r>
-              <a:rPr sz="2000" b="1" dirty="0">
-                <a:solidFill>
-                  <a:srgbClr val="475569"/>
-                </a:solidFill>
-                <a:latin typeface="Noto Sans SemiBold"/>
-              </a:rPr>
-              <a:t> </a:t>
-            </a:r>
-            <a:r>
-              <a:rPr lang="en-GB" sz="2000" b="1" dirty="0">
-                <a:solidFill>
-                  <a:srgbClr val="475569"/>
-                </a:solidFill>
-                <a:latin typeface="Noto Sans SemiBold"/>
-              </a:rPr>
-              <a:t>{{PRESENT_FORM}}</a:t>
-            </a:r>
-            <a:r>
-              <a:rPr sz="1600" b="1" dirty="0"/>
-              <a:t>
-</a:t>
-            </a:r>
-            <a:r>
-              <a:rPr sz="2000" b="1" dirty="0">
-                <a:solidFill>
-                  <a:srgbClr val="475569"/>
-                </a:solidFill>
-                <a:latin typeface="Noto Sans SemiBold"/>
-              </a:rPr>
-              <a:t> </a:t>
-            </a:r>
-            <a:r>
-              <a:rPr lang="en-GB" sz="2000" b="1" dirty="0">
-                <a:solidFill>
-                  <a:srgbClr val="475569"/>
-                </a:solidFill>
-                <a:latin typeface="Noto Sans SemiBold"/>
-              </a:rPr>
-              <a:t>{{PAST_FORM}}</a:t>
-            </a:r>
-            <a:endParaRPr sz="2000" b="1" dirty="0">
-              <a:solidFill>
-                <a:srgbClr val="475569"/>
-              </a:solidFill>
-              <a:latin typeface="Noto Sans SemiBold"/>
-            </a:endParaRPr>
-          </a:p>
-        </p:txBody>
-      </p:sp>
-      <p:sp>
-        <p:nvSpPr>
-          <p:cNvPr id="21" name="TextBox 20">
-            <a:extLst>
-              <a:ext uri="{FF2B5EF4-FFF2-40B4-BE49-F238E27FC236}">
-                <a16:creationId xmlns:a16="http://schemas.microsoft.com/office/drawing/2014/main" id="{590BF58F-2AA1-5ACF-5E4F-09BCECD71671}"/>
-              </a:ext>
-            </a:extLst>
-          </p:cNvPr>
-          <p:cNvSpPr txBox="1"/>
-          <p:nvPr/>
-        </p:nvSpPr>
-        <p:spPr>
-          <a:xfrm>
-            <a:off x="4889704" y="2256576"/>
+            <a:off x="4889704" y="2457390"/>
             <a:ext cx="3806620" cy="1107996"/>
           </a:xfrm>
           <a:prstGeom prst="rect">
@@ -5037,117 +5148,6 @@
                 <a:srgbClr val="475569"/>
               </a:solidFill>
               <a:latin typeface="Noto Sans SemiBold"/>
-            </a:endParaRPr>
-          </a:p>
-        </p:txBody>
-      </p:sp>
-      <p:sp>
-        <p:nvSpPr>
-          <p:cNvPr id="23" name="TextBox 22">
-            <a:extLst>
-              <a:ext uri="{FF2B5EF4-FFF2-40B4-BE49-F238E27FC236}">
-                <a16:creationId xmlns:a16="http://schemas.microsoft.com/office/drawing/2014/main" id="{65D623EB-2A7F-7E13-A27F-15A5483F3E36}"/>
-              </a:ext>
-            </a:extLst>
-          </p:cNvPr>
-          <p:cNvSpPr txBox="1"/>
-          <p:nvPr/>
-        </p:nvSpPr>
-        <p:spPr>
-          <a:xfrm>
-            <a:off x="2630128" y="4432329"/>
-            <a:ext cx="9202532" cy="369332"/>
-          </a:xfrm>
-          <a:prstGeom prst="rect">
-            <a:avLst/>
-          </a:prstGeom>
-          <a:noFill/>
-        </p:spPr>
-        <p:txBody>
-          <a:bodyPr wrap="square" lIns="0" tIns="0" rIns="0" bIns="0" anchor="t">
-            <a:spAutoFit/>
-          </a:bodyPr>
-          <a:lstStyle/>
-          <a:p>
-            <a:r>
-              <a:rPr lang="en-GB" sz="2400" b="0" i="0" u="none" dirty="0">
-                <a:solidFill>
-                  <a:srgbClr val="2A3644"/>
-                </a:solidFill>
-                <a:latin typeface="Poppins ExtraBold"/>
-              </a:rPr>
-              <a:t>{{PAST_SENTENCE}}</a:t>
-            </a:r>
-            <a:endParaRPr sz="2400" b="0" i="0" u="none" dirty="0">
-              <a:solidFill>
-                <a:srgbClr val="2A3644"/>
-              </a:solidFill>
-              <a:latin typeface="Poppins ExtraBold"/>
-            </a:endParaRPr>
-          </a:p>
-        </p:txBody>
-      </p:sp>
-      <p:sp>
-        <p:nvSpPr>
-          <p:cNvPr id="25" name="TextBox 24">
-            <a:extLst>
-              <a:ext uri="{FF2B5EF4-FFF2-40B4-BE49-F238E27FC236}">
-                <a16:creationId xmlns:a16="http://schemas.microsoft.com/office/drawing/2014/main" id="{4D793BF9-6668-B68C-6469-0785C86AA080}"/>
-              </a:ext>
-            </a:extLst>
-          </p:cNvPr>
-          <p:cNvSpPr txBox="1"/>
-          <p:nvPr/>
-        </p:nvSpPr>
-        <p:spPr>
-          <a:xfrm>
-            <a:off x="7277098" y="1425516"/>
-            <a:ext cx="2838451" cy="253916"/>
-          </a:xfrm>
-          <a:prstGeom prst="rect">
-            <a:avLst/>
-          </a:prstGeom>
-          <a:noFill/>
-        </p:spPr>
-        <p:txBody>
-          <a:bodyPr wrap="square" lIns="0" tIns="0" rIns="0" bIns="0" anchor="ctr">
-            <a:spAutoFit/>
-          </a:bodyPr>
-          <a:lstStyle/>
-          <a:p>
-            <a:pPr algn="ctr"/>
-            <a:r>
-              <a:rPr lang="en-GB" sz="1650" u="none" dirty="0">
-                <a:solidFill>
-                  <a:srgbClr val="472D33"/>
-                </a:solidFill>
-                <a:latin typeface="Poppins ExtraBold"/>
-              </a:rPr>
-              <a:t>{{</a:t>
-            </a:r>
-            <a:r>
-              <a:rPr lang="en-GB" sz="1400" dirty="0">
-                <a:solidFill>
-                  <a:srgbClr val="472D33"/>
-                </a:solidFill>
-                <a:latin typeface="Poppins ExtraBold"/>
-              </a:rPr>
-              <a:t>PRONUNCIATION</a:t>
-            </a:r>
-            <a:r>
-              <a:rPr lang="en-GB" sz="1650" u="none" dirty="0">
-                <a:solidFill>
-                  <a:srgbClr val="472D33"/>
-                </a:solidFill>
-                <a:latin typeface="Poppins ExtraBold"/>
-              </a:rPr>
-              <a:t>}}</a:t>
-            </a:r>
-            <a:endParaRPr sz="1650" u="none" dirty="0">
-              <a:solidFill>
-                <a:srgbClr val="472D33"/>
-              </a:solidFill>
-              <a:latin typeface="Poppins ExtraBold"/>
             </a:endParaRPr>
           </a:p>
         </p:txBody>
@@ -5410,7 +5410,7 @@
         </p:nvSpPr>
         <p:spPr>
           <a:xfrm>
-            <a:off x="3151085" y="5852149"/>
+            <a:off x="2630128" y="5984803"/>
             <a:ext cx="7560085" cy="369332"/>
           </a:xfrm>
           <a:prstGeom prst="rect">
@@ -5543,12 +5543,216 @@
           </a:p>
         </p:txBody>
       </p:sp>
+      <p:sp>
+        <p:nvSpPr>
+          <p:cNvPr id="20" name="TextBox 19">
+            <a:extLst>
+              <a:ext uri="{FF2B5EF4-FFF2-40B4-BE49-F238E27FC236}">
+                <a16:creationId xmlns:a16="http://schemas.microsoft.com/office/drawing/2014/main" id="{C1FEC5A9-E247-9090-8B5E-DF195BFCAB9D}"/>
+              </a:ext>
+            </a:extLst>
+          </p:cNvPr>
+          <p:cNvSpPr txBox="1"/>
+          <p:nvPr/>
+        </p:nvSpPr>
+        <p:spPr>
+          <a:xfrm>
+            <a:off x="8820449" y="2549723"/>
+            <a:ext cx="3412926" cy="923330"/>
+          </a:xfrm>
+          <a:prstGeom prst="rect">
+            <a:avLst/>
+          </a:prstGeom>
+          <a:noFill/>
+        </p:spPr>
+        <p:txBody>
+          <a:bodyPr wrap="square" lIns="0" tIns="0" rIns="0" bIns="0" anchor="t">
+            <a:spAutoFit/>
+          </a:bodyPr>
+          <a:lstStyle/>
+          <a:p>
+            <a:pPr algn="ctr"/>
+            <a:r>
+              <a:rPr lang="en-GB" sz="2000" b="1" dirty="0">
+                <a:solidFill>
+                  <a:srgbClr val="475569"/>
+                </a:solidFill>
+                <a:latin typeface="Noto Sans SemiBold"/>
+              </a:rPr>
+              <a:t>{{BASE_FORM}}</a:t>
+            </a:r>
+            <a:r>
+              <a:rPr sz="1600" b="1" dirty="0"/>
+              <a:t>
+</a:t>
+            </a:r>
+            <a:r>
+              <a:rPr sz="2000" b="1" dirty="0">
+                <a:solidFill>
+                  <a:srgbClr val="475569"/>
+                </a:solidFill>
+                <a:latin typeface="Noto Sans SemiBold"/>
+              </a:rPr>
+              <a:t> </a:t>
+            </a:r>
+            <a:r>
+              <a:rPr lang="en-GB" sz="2000" b="1" dirty="0">
+                <a:solidFill>
+                  <a:srgbClr val="475569"/>
+                </a:solidFill>
+                <a:latin typeface="Noto Sans SemiBold"/>
+              </a:rPr>
+              <a:t>{{PRESENT_FORM}}</a:t>
+            </a:r>
+            <a:r>
+              <a:rPr sz="1600" b="1" dirty="0"/>
+              <a:t>
+</a:t>
+            </a:r>
+            <a:r>
+              <a:rPr sz="2000" b="1" dirty="0">
+                <a:solidFill>
+                  <a:srgbClr val="475569"/>
+                </a:solidFill>
+                <a:latin typeface="Noto Sans SemiBold"/>
+              </a:rPr>
+              <a:t> </a:t>
+            </a:r>
+            <a:r>
+              <a:rPr lang="en-GB" sz="2000" b="1" dirty="0">
+                <a:solidFill>
+                  <a:srgbClr val="475569"/>
+                </a:solidFill>
+                <a:latin typeface="Noto Sans SemiBold"/>
+              </a:rPr>
+              <a:t>{{PAST_FORM}}</a:t>
+            </a:r>
+            <a:endParaRPr sz="2000" b="1" dirty="0">
+              <a:solidFill>
+                <a:srgbClr val="475569"/>
+              </a:solidFill>
+              <a:latin typeface="Noto Sans SemiBold"/>
+            </a:endParaRPr>
+          </a:p>
+        </p:txBody>
+      </p:sp>
+      <p:sp>
+        <p:nvSpPr>
+          <p:cNvPr id="26" name="TextBox 25">
+            <a:extLst>
+              <a:ext uri="{FF2B5EF4-FFF2-40B4-BE49-F238E27FC236}">
+                <a16:creationId xmlns:a16="http://schemas.microsoft.com/office/drawing/2014/main" id="{1612C5B2-CFF0-4A87-C883-30EC409E492D}"/>
+              </a:ext>
+            </a:extLst>
+          </p:cNvPr>
+          <p:cNvSpPr txBox="1"/>
+          <p:nvPr/>
+        </p:nvSpPr>
+        <p:spPr>
+          <a:xfrm>
+            <a:off x="2630128" y="4432329"/>
+            <a:ext cx="9202532" cy="369332"/>
+          </a:xfrm>
+          <a:prstGeom prst="rect">
+            <a:avLst/>
+          </a:prstGeom>
+          <a:noFill/>
+        </p:spPr>
+        <p:txBody>
+          <a:bodyPr wrap="square" lIns="0" tIns="0" rIns="0" bIns="0" anchor="t">
+            <a:spAutoFit/>
+          </a:bodyPr>
+          <a:lstStyle/>
+          <a:p>
+            <a:r>
+              <a:rPr lang="en-GB" sz="2400" b="0" i="0" u="none" dirty="0">
+                <a:solidFill>
+                  <a:srgbClr val="2A3644"/>
+                </a:solidFill>
+                <a:latin typeface="Poppins ExtraBold"/>
+              </a:rPr>
+              <a:t>{{PAST_SENTENCE}}</a:t>
+            </a:r>
+            <a:endParaRPr sz="2400" b="0" i="0" u="none" dirty="0">
+              <a:solidFill>
+                <a:srgbClr val="2A3644"/>
+              </a:solidFill>
+              <a:latin typeface="Poppins ExtraBold"/>
+            </a:endParaRPr>
+          </a:p>
+        </p:txBody>
+      </p:sp>
+      <p:sp>
+        <p:nvSpPr>
+          <p:cNvPr id="32" name="TextBox 31">
+            <a:extLst>
+              <a:ext uri="{FF2B5EF4-FFF2-40B4-BE49-F238E27FC236}">
+                <a16:creationId xmlns:a16="http://schemas.microsoft.com/office/drawing/2014/main" id="{DE2C92EE-F42D-1CE7-8EE0-7AE90461F18C}"/>
+              </a:ext>
+            </a:extLst>
+          </p:cNvPr>
+          <p:cNvSpPr txBox="1"/>
+          <p:nvPr/>
+        </p:nvSpPr>
+        <p:spPr>
+          <a:xfrm>
+            <a:off x="7277098" y="1425516"/>
+            <a:ext cx="2838451" cy="253916"/>
+          </a:xfrm>
+          <a:prstGeom prst="rect">
+            <a:avLst/>
+          </a:prstGeom>
+          <a:noFill/>
+        </p:spPr>
+        <p:txBody>
+          <a:bodyPr wrap="square" lIns="0" tIns="0" rIns="0" bIns="0" anchor="ctr">
+            <a:spAutoFit/>
+          </a:bodyPr>
+          <a:lstStyle/>
+          <a:p>
+            <a:pPr algn="ctr"/>
+            <a:r>
+              <a:rPr lang="en-GB" sz="1650" u="none" dirty="0">
+                <a:solidFill>
+                  <a:srgbClr val="472D33"/>
+                </a:solidFill>
+                <a:latin typeface="Poppins ExtraBold"/>
+              </a:rPr>
+              <a:t>{{</a:t>
+            </a:r>
+            <a:r>
+              <a:rPr lang="en-GB" sz="1400" dirty="0">
+                <a:solidFill>
+                  <a:srgbClr val="472D33"/>
+                </a:solidFill>
+                <a:latin typeface="Poppins ExtraBold"/>
+              </a:rPr>
+              <a:t>PRONUNCIATION</a:t>
+            </a:r>
+            <a:r>
+              <a:rPr lang="en-GB" sz="1650" u="none" dirty="0">
+                <a:solidFill>
+                  <a:srgbClr val="472D33"/>
+                </a:solidFill>
+                <a:latin typeface="Poppins ExtraBold"/>
+              </a:rPr>
+              <a:t>}}</a:t>
+            </a:r>
+            <a:endParaRPr sz="1650" u="none" dirty="0">
+              <a:solidFill>
+                <a:srgbClr val="472D33"/>
+              </a:solidFill>
+              <a:latin typeface="Poppins ExtraBold"/>
+            </a:endParaRPr>
+          </a:p>
+        </p:txBody>
+      </p:sp>
       <p:pic>
         <p:nvPicPr>
-          <p:cNvPr id="18" name="VOCAB_IMAGE" descr="image.png">
+          <p:cNvPr id="4" name="VOCAB_IMAGE" descr="image.png">
             <a:extLst>
               <a:ext uri="{FF2B5EF4-FFF2-40B4-BE49-F238E27FC236}">
-                <a16:creationId xmlns:a16="http://schemas.microsoft.com/office/drawing/2014/main" id="{FBA18E64-1E4C-2FB8-27F8-121619540CB0}"/>
+                <a16:creationId xmlns:a16="http://schemas.microsoft.com/office/drawing/2014/main" id="{453A244D-653E-CCB6-F580-EB06975F031E}"/>
               </a:ext>
             </a:extLst>
           </p:cNvPr>
@@ -5565,8 +5769,8 @@
         </p:blipFill>
         <p:spPr>
           <a:xfrm>
-            <a:off x="540774" y="151320"/>
-            <a:ext cx="4178709" cy="3406118"/>
+            <a:off x="0" y="7061"/>
+            <a:ext cx="4719484" cy="3550377"/>
           </a:xfrm>
           <a:prstGeom prst="rect">
             <a:avLst/>
@@ -5575,10 +5779,10 @@
       </p:pic>
       <p:sp>
         <p:nvSpPr>
-          <p:cNvPr id="20" name="TextBox 19">
+          <p:cNvPr id="9" name="TextBox 8">
             <a:extLst>
               <a:ext uri="{FF2B5EF4-FFF2-40B4-BE49-F238E27FC236}">
-                <a16:creationId xmlns:a16="http://schemas.microsoft.com/office/drawing/2014/main" id="{C1FEC5A9-E247-9090-8B5E-DF195BFCAB9D}"/>
+                <a16:creationId xmlns:a16="http://schemas.microsoft.com/office/drawing/2014/main" id="{DE46360C-C842-CACE-C3FF-8EBF6C160A9D}"/>
               </a:ext>
             </a:extLst>
           </p:cNvPr>
@@ -5587,100 +5791,7 @@
         </p:nvSpPr>
         <p:spPr>
           <a:xfrm>
-            <a:off x="8820449" y="2549723"/>
-            <a:ext cx="3412926" cy="923330"/>
-          </a:xfrm>
-          <a:prstGeom prst="rect">
-            <a:avLst/>
-          </a:prstGeom>
-          <a:noFill/>
-        </p:spPr>
-        <p:txBody>
-          <a:bodyPr wrap="square" lIns="0" tIns="0" rIns="0" bIns="0" anchor="t">
-            <a:spAutoFit/>
-          </a:bodyPr>
-          <a:lstStyle/>
-          <a:p>
-            <a:pPr algn="ctr"/>
-            <a:r>
-              <a:rPr lang="en-GB" sz="2000" b="1" dirty="0">
-                <a:solidFill>
-                  <a:srgbClr val="475569"/>
-                </a:solidFill>
-                <a:latin typeface="Noto Sans SemiBold"/>
-              </a:rPr>
-              <a:t>{{BASE_FORM}}</a:t>
-            </a:r>
-            <a:r>
-              <a:rPr sz="1600" b="1" dirty="0"/>
-              <a:t>
-</a:t>
-            </a:r>
-            <a:r>
-              <a:rPr sz="2000" b="1" dirty="0">
-                <a:solidFill>
-                  <a:srgbClr val="475569"/>
-                </a:solidFill>
-                <a:latin typeface="Noto Sans SemiBold"/>
-              </a:rPr>
-              <a:t> </a:t>
-            </a:r>
-            <a:r>
-              <a:rPr lang="en-GB" sz="2000" b="1" dirty="0">
-                <a:solidFill>
-                  <a:srgbClr val="475569"/>
-                </a:solidFill>
-                <a:latin typeface="Noto Sans SemiBold"/>
-              </a:rPr>
-              <a:t>{{PRESENT_FORM}}</a:t>
-            </a:r>
-            <a:r>
-              <a:rPr sz="1600" b="1" dirty="0"/>
-              <a:t>
-</a:t>
-            </a:r>
-            <a:r>
-              <a:rPr sz="2000" b="1" dirty="0">
-                <a:solidFill>
-                  <a:srgbClr val="475569"/>
-                </a:solidFill>
-                <a:latin typeface="Noto Sans SemiBold"/>
-              </a:rPr>
-              <a:t> </a:t>
-            </a:r>
-            <a:r>
-              <a:rPr lang="en-GB" sz="2000" b="1" dirty="0">
-                <a:solidFill>
-                  <a:srgbClr val="475569"/>
-                </a:solidFill>
-                <a:latin typeface="Noto Sans SemiBold"/>
-              </a:rPr>
-              <a:t>{{PAST_FORM}}</a:t>
-            </a:r>
-            <a:endParaRPr sz="2000" b="1" dirty="0">
-              <a:solidFill>
-                <a:srgbClr val="475569"/>
-              </a:solidFill>
-              <a:latin typeface="Noto Sans SemiBold"/>
-            </a:endParaRPr>
-          </a:p>
-        </p:txBody>
-      </p:sp>
-      <p:sp>
-        <p:nvSpPr>
-          <p:cNvPr id="22" name="TextBox 21">
-            <a:extLst>
-              <a:ext uri="{FF2B5EF4-FFF2-40B4-BE49-F238E27FC236}">
-                <a16:creationId xmlns:a16="http://schemas.microsoft.com/office/drawing/2014/main" id="{4EBBDC52-4415-C3D9-2821-786E9566F9C4}"/>
-              </a:ext>
-            </a:extLst>
-          </p:cNvPr>
-          <p:cNvSpPr txBox="1"/>
-          <p:nvPr/>
-        </p:nvSpPr>
-        <p:spPr>
-          <a:xfrm>
-            <a:off x="4889704" y="2256576"/>
+            <a:off x="4889704" y="2457390"/>
             <a:ext cx="3806620" cy="1107996"/>
           </a:xfrm>
           <a:prstGeom prst="rect">
@@ -5833,10 +5944,10 @@
       </p:sp>
       <p:sp>
         <p:nvSpPr>
-          <p:cNvPr id="24" name="TextBox 23">
+          <p:cNvPr id="13" name="TextBox 12">
             <a:extLst>
               <a:ext uri="{FF2B5EF4-FFF2-40B4-BE49-F238E27FC236}">
-                <a16:creationId xmlns:a16="http://schemas.microsoft.com/office/drawing/2014/main" id="{F8ACC22F-7B3D-34DE-DA3D-5C15B7717514}"/>
+                <a16:creationId xmlns:a16="http://schemas.microsoft.com/office/drawing/2014/main" id="{4A6F48EE-5878-99D8-5636-D1B0BA937A96}"/>
               </a:ext>
             </a:extLst>
           </p:cNvPr>
@@ -5845,7 +5956,7 @@
         </p:nvSpPr>
         <p:spPr>
           <a:xfrm>
-            <a:off x="2843902" y="5157522"/>
+            <a:off x="2630128" y="5247818"/>
             <a:ext cx="8774983" cy="369332"/>
           </a:xfrm>
           <a:prstGeom prst="rect">
@@ -5889,117 +6000,6 @@
             <a:endParaRPr sz="2400" b="0" i="0" u="none" dirty="0">
               <a:solidFill>
                 <a:srgbClr val="2A3644"/>
-              </a:solidFill>
-              <a:latin typeface="Poppins ExtraBold"/>
-            </a:endParaRPr>
-          </a:p>
-        </p:txBody>
-      </p:sp>
-      <p:sp>
-        <p:nvSpPr>
-          <p:cNvPr id="26" name="TextBox 25">
-            <a:extLst>
-              <a:ext uri="{FF2B5EF4-FFF2-40B4-BE49-F238E27FC236}">
-                <a16:creationId xmlns:a16="http://schemas.microsoft.com/office/drawing/2014/main" id="{1612C5B2-CFF0-4A87-C883-30EC409E492D}"/>
-              </a:ext>
-            </a:extLst>
-          </p:cNvPr>
-          <p:cNvSpPr txBox="1"/>
-          <p:nvPr/>
-        </p:nvSpPr>
-        <p:spPr>
-          <a:xfrm>
-            <a:off x="2630128" y="4432329"/>
-            <a:ext cx="9202532" cy="369332"/>
-          </a:xfrm>
-          <a:prstGeom prst="rect">
-            <a:avLst/>
-          </a:prstGeom>
-          <a:noFill/>
-        </p:spPr>
-        <p:txBody>
-          <a:bodyPr wrap="square" lIns="0" tIns="0" rIns="0" bIns="0" anchor="t">
-            <a:spAutoFit/>
-          </a:bodyPr>
-          <a:lstStyle/>
-          <a:p>
-            <a:r>
-              <a:rPr lang="en-GB" sz="2400" b="0" i="0" u="none" dirty="0">
-                <a:solidFill>
-                  <a:srgbClr val="2A3644"/>
-                </a:solidFill>
-                <a:latin typeface="Poppins ExtraBold"/>
-              </a:rPr>
-              <a:t>{{PAST_SENTENCE}}</a:t>
-            </a:r>
-            <a:endParaRPr sz="2400" b="0" i="0" u="none" dirty="0">
-              <a:solidFill>
-                <a:srgbClr val="2A3644"/>
-              </a:solidFill>
-              <a:latin typeface="Poppins ExtraBold"/>
-            </a:endParaRPr>
-          </a:p>
-        </p:txBody>
-      </p:sp>
-      <p:sp>
-        <p:nvSpPr>
-          <p:cNvPr id="32" name="TextBox 31">
-            <a:extLst>
-              <a:ext uri="{FF2B5EF4-FFF2-40B4-BE49-F238E27FC236}">
-                <a16:creationId xmlns:a16="http://schemas.microsoft.com/office/drawing/2014/main" id="{DE2C92EE-F42D-1CE7-8EE0-7AE90461F18C}"/>
-              </a:ext>
-            </a:extLst>
-          </p:cNvPr>
-          <p:cNvSpPr txBox="1"/>
-          <p:nvPr/>
-        </p:nvSpPr>
-        <p:spPr>
-          <a:xfrm>
-            <a:off x="7277098" y="1425516"/>
-            <a:ext cx="2838451" cy="253916"/>
-          </a:xfrm>
-          <a:prstGeom prst="rect">
-            <a:avLst/>
-          </a:prstGeom>
-          <a:noFill/>
-        </p:spPr>
-        <p:txBody>
-          <a:bodyPr wrap="square" lIns="0" tIns="0" rIns="0" bIns="0" anchor="ctr">
-            <a:spAutoFit/>
-          </a:bodyPr>
-          <a:lstStyle/>
-          <a:p>
-            <a:pPr algn="ctr"/>
-            <a:r>
-              <a:rPr lang="en-GB" sz="1650" u="none" dirty="0">
-                <a:solidFill>
-                  <a:srgbClr val="472D33"/>
-                </a:solidFill>
-                <a:latin typeface="Poppins ExtraBold"/>
-              </a:rPr>
-              <a:t>{{</a:t>
-            </a:r>
-            <a:r>
-              <a:rPr lang="en-GB" sz="1400" dirty="0">
-                <a:solidFill>
-                  <a:srgbClr val="472D33"/>
-                </a:solidFill>
-                <a:latin typeface="Poppins ExtraBold"/>
-              </a:rPr>
-              <a:t>PRONUNCIATION</a:t>
-            </a:r>
-            <a:r>
-              <a:rPr lang="en-GB" sz="1650" u="none" dirty="0">
-                <a:solidFill>
-                  <a:srgbClr val="472D33"/>
-                </a:solidFill>
-                <a:latin typeface="Poppins ExtraBold"/>
-              </a:rPr>
-              <a:t>}}</a:t>
-            </a:r>
-            <a:endParaRPr sz="1650" u="none" dirty="0">
-              <a:solidFill>
-                <a:srgbClr val="472D33"/>
               </a:solidFill>
               <a:latin typeface="Poppins ExtraBold"/>
             </a:endParaRPr>

</xml_diff>

<commit_message>
Update vocabulary presentation template layout
</commit_message>
<xml_diff>
--- a/templates/vocabulary_template_v3.pptx
+++ b/templates/vocabulary_template_v3.pptx
@@ -305,7 +305,7 @@
           <a:p>
             <a:fld id="{5BCAD085-E8A6-8845-BD4E-CB4CCA059FC4}" type="datetimeFigureOut">
               <a:rPr lang="en-US" smtClean="0"/>
-              <a:t>8/20/2026</a:t>
+              <a:t>8/21/2026</a:t>
             </a:fld>
             <a:endParaRPr lang="en-US"/>
           </a:p>
@@ -473,7 +473,7 @@
           <a:p>
             <a:fld id="{5BCAD085-E8A6-8845-BD4E-CB4CCA059FC4}" type="datetimeFigureOut">
               <a:rPr lang="en-US" smtClean="0"/>
-              <a:t>8/20/2026</a:t>
+              <a:t>8/21/2026</a:t>
             </a:fld>
             <a:endParaRPr lang="en-US"/>
           </a:p>
@@ -651,7 +651,7 @@
           <a:p>
             <a:fld id="{5BCAD085-E8A6-8845-BD4E-CB4CCA059FC4}" type="datetimeFigureOut">
               <a:rPr lang="en-US" smtClean="0"/>
-              <a:t>8/20/2026</a:t>
+              <a:t>8/21/2026</a:t>
             </a:fld>
             <a:endParaRPr lang="en-US"/>
           </a:p>
@@ -819,7 +819,7 @@
           <a:p>
             <a:fld id="{5BCAD085-E8A6-8845-BD4E-CB4CCA059FC4}" type="datetimeFigureOut">
               <a:rPr lang="en-US" smtClean="0"/>
-              <a:t>8/20/2026</a:t>
+              <a:t>8/21/2026</a:t>
             </a:fld>
             <a:endParaRPr lang="en-US"/>
           </a:p>
@@ -1064,7 +1064,7 @@
           <a:p>
             <a:fld id="{5BCAD085-E8A6-8845-BD4E-CB4CCA059FC4}" type="datetimeFigureOut">
               <a:rPr lang="en-US" smtClean="0"/>
-              <a:t>8/20/2026</a:t>
+              <a:t>8/21/2026</a:t>
             </a:fld>
             <a:endParaRPr lang="en-US"/>
           </a:p>
@@ -1349,7 +1349,7 @@
           <a:p>
             <a:fld id="{5BCAD085-E8A6-8845-BD4E-CB4CCA059FC4}" type="datetimeFigureOut">
               <a:rPr lang="en-US" smtClean="0"/>
-              <a:t>8/20/2026</a:t>
+              <a:t>8/21/2026</a:t>
             </a:fld>
             <a:endParaRPr lang="en-US"/>
           </a:p>
@@ -1768,7 +1768,7 @@
           <a:p>
             <a:fld id="{5BCAD085-E8A6-8845-BD4E-CB4CCA059FC4}" type="datetimeFigureOut">
               <a:rPr lang="en-US" smtClean="0"/>
-              <a:t>8/20/2026</a:t>
+              <a:t>8/21/2026</a:t>
             </a:fld>
             <a:endParaRPr lang="en-US"/>
           </a:p>
@@ -1885,7 +1885,7 @@
           <a:p>
             <a:fld id="{5BCAD085-E8A6-8845-BD4E-CB4CCA059FC4}" type="datetimeFigureOut">
               <a:rPr lang="en-US" smtClean="0"/>
-              <a:t>8/20/2026</a:t>
+              <a:t>8/21/2026</a:t>
             </a:fld>
             <a:endParaRPr lang="en-US"/>
           </a:p>
@@ -1980,7 +1980,7 @@
           <a:p>
             <a:fld id="{5BCAD085-E8A6-8845-BD4E-CB4CCA059FC4}" type="datetimeFigureOut">
               <a:rPr lang="en-US" smtClean="0"/>
-              <a:t>8/20/2026</a:t>
+              <a:t>8/21/2026</a:t>
             </a:fld>
             <a:endParaRPr lang="en-US"/>
           </a:p>
@@ -2255,7 +2255,7 @@
           <a:p>
             <a:fld id="{5BCAD085-E8A6-8845-BD4E-CB4CCA059FC4}" type="datetimeFigureOut">
               <a:rPr lang="en-US" smtClean="0"/>
-              <a:t>8/20/2026</a:t>
+              <a:t>8/21/2026</a:t>
             </a:fld>
             <a:endParaRPr lang="en-US"/>
           </a:p>
@@ -2507,7 +2507,7 @@
           <a:p>
             <a:fld id="{5BCAD085-E8A6-8845-BD4E-CB4CCA059FC4}" type="datetimeFigureOut">
               <a:rPr lang="en-US" smtClean="0"/>
-              <a:t>8/20/2026</a:t>
+              <a:t>8/21/2026</a:t>
             </a:fld>
             <a:endParaRPr lang="en-US"/>
           </a:p>
@@ -2718,7 +2718,7 @@
           <a:p>
             <a:fld id="{5BCAD085-E8A6-8845-BD4E-CB4CCA059FC4}" type="datetimeFigureOut">
               <a:rPr lang="en-US" smtClean="0"/>
-              <a:t>8/20/2026</a:t>
+              <a:t>8/21/2026</a:t>
             </a:fld>
             <a:endParaRPr lang="en-US"/>
           </a:p>
@@ -3133,7 +3133,7 @@
         </p:nvSpPr>
         <p:spPr>
           <a:xfrm>
-            <a:off x="7277098" y="1425516"/>
+            <a:off x="7277098" y="1318246"/>
             <a:ext cx="2838451" cy="253916"/>
           </a:xfrm>
           <a:prstGeom prst="rect">
@@ -3240,8 +3240,8 @@
         </p:nvSpPr>
         <p:spPr>
           <a:xfrm>
-            <a:off x="5869858" y="380999"/>
-            <a:ext cx="5781368" cy="1171475"/>
+            <a:off x="5515897" y="213702"/>
+            <a:ext cx="6517097" cy="1171475"/>
           </a:xfrm>
           <a:prstGeom prst="rect">
             <a:avLst/>
@@ -3285,7 +3285,7 @@
         </p:nvSpPr>
         <p:spPr>
           <a:xfrm>
-            <a:off x="5652935" y="1760255"/>
+            <a:off x="5697178" y="1633750"/>
             <a:ext cx="5998291" cy="415498"/>
           </a:xfrm>
           <a:prstGeom prst="rect">
@@ -3326,7 +3326,7 @@
         </p:nvSpPr>
         <p:spPr>
           <a:xfrm>
-            <a:off x="4889704" y="2457390"/>
+            <a:off x="4889704" y="2526335"/>
             <a:ext cx="3806620" cy="1107996"/>
           </a:xfrm>
           <a:prstGeom prst="rect">
@@ -3811,71 +3811,6 @@
           </a:p>
         </p:txBody>
       </p:sp>
-      <p:sp>
-        <p:nvSpPr>
-          <p:cNvPr id="4" name="TextBox 3">
-            <a:extLst>
-              <a:ext uri="{FF2B5EF4-FFF2-40B4-BE49-F238E27FC236}">
-                <a16:creationId xmlns:a16="http://schemas.microsoft.com/office/drawing/2014/main" id="{C45EB1EB-12A8-4C78-7555-C064C72F1E0A}"/>
-              </a:ext>
-            </a:extLst>
-          </p:cNvPr>
-          <p:cNvSpPr txBox="1"/>
-          <p:nvPr/>
-        </p:nvSpPr>
-        <p:spPr>
-          <a:xfrm>
-            <a:off x="7277098" y="1425516"/>
-            <a:ext cx="2838451" cy="253916"/>
-          </a:xfrm>
-          <a:prstGeom prst="rect">
-            <a:avLst/>
-          </a:prstGeom>
-          <a:noFill/>
-        </p:spPr>
-        <p:txBody>
-          <a:bodyPr wrap="square" lIns="0" tIns="0" rIns="0" bIns="0" anchor="ctr">
-            <a:spAutoFit/>
-          </a:bodyPr>
-          <a:lstStyle/>
-          <a:p>
-            <a:pPr algn="ctr"/>
-            <a:r>
-              <a:rPr lang="en-GB" sz="1650" u="none" dirty="0">
-                <a:solidFill>
-                  <a:srgbClr val="472D33"/>
-                </a:solidFill>
-                <a:latin typeface="Poppins ExtraBold"/>
-              </a:rPr>
-              <a:t>{{</a:t>
-            </a:r>
-            <a:r>
-              <a:rPr lang="en-GB" sz="1400" dirty="0">
-                <a:solidFill>
-                  <a:srgbClr val="472D33"/>
-                </a:solidFill>
-                <a:latin typeface="Poppins ExtraBold"/>
-              </a:rPr>
-              <a:t>PRONUNCIATION</a:t>
-            </a:r>
-            <a:r>
-              <a:rPr lang="en-GB" sz="1650" u="none" dirty="0">
-                <a:solidFill>
-                  <a:srgbClr val="472D33"/>
-                </a:solidFill>
-                <a:latin typeface="Poppins ExtraBold"/>
-              </a:rPr>
-              <a:t>}}</a:t>
-            </a:r>
-            <a:endParaRPr sz="1650" u="none" dirty="0">
-              <a:solidFill>
-                <a:srgbClr val="472D33"/>
-              </a:solidFill>
-              <a:latin typeface="Poppins ExtraBold"/>
-            </a:endParaRPr>
-          </a:p>
-        </p:txBody>
-      </p:sp>
       <p:pic>
         <p:nvPicPr>
           <p:cNvPr id="5" name="Picture 4" descr="image.png">
@@ -3906,104 +3841,6 @@
           </a:prstGeom>
         </p:spPr>
       </p:pic>
-      <p:sp>
-        <p:nvSpPr>
-          <p:cNvPr id="7" name="TextBox 6">
-            <a:extLst>
-              <a:ext uri="{FF2B5EF4-FFF2-40B4-BE49-F238E27FC236}">
-                <a16:creationId xmlns:a16="http://schemas.microsoft.com/office/drawing/2014/main" id="{AB967A89-D0B6-0911-7979-8252ABD5BB96}"/>
-              </a:ext>
-            </a:extLst>
-          </p:cNvPr>
-          <p:cNvSpPr txBox="1"/>
-          <p:nvPr/>
-        </p:nvSpPr>
-        <p:spPr>
-          <a:xfrm>
-            <a:off x="5869858" y="380999"/>
-            <a:ext cx="5781368" cy="1171475"/>
-          </a:xfrm>
-          <a:prstGeom prst="rect">
-            <a:avLst/>
-          </a:prstGeom>
-          <a:noFill/>
-        </p:spPr>
-        <p:txBody>
-          <a:bodyPr wrap="square" lIns="0" tIns="0" rIns="0" bIns="0" anchor="t">
-            <a:spAutoFit/>
-          </a:bodyPr>
-          <a:lstStyle/>
-          <a:p>
-            <a:pPr algn="ctr">
-              <a:lnSpc>
-                <a:spcPts val="9075"/>
-              </a:lnSpc>
-            </a:pPr>
-            <a:r>
-              <a:rPr lang="en-GB" sz="7400" b="0" i="0" u="none" dirty="0">
-                <a:solidFill>
-                  <a:srgbClr val="0F172A"/>
-                </a:solidFill>
-                <a:latin typeface="Poppins ExtraBold"/>
-              </a:rPr>
-              <a:t>{{WORD}}</a:t>
-            </a:r>
-            <a:endParaRPr sz="7400" b="0" i="0" u="none" dirty="0">
-              <a:solidFill>
-                <a:srgbClr val="0F172A"/>
-              </a:solidFill>
-              <a:latin typeface="Poppins ExtraBold"/>
-            </a:endParaRPr>
-          </a:p>
-        </p:txBody>
-      </p:sp>
-      <p:sp>
-        <p:nvSpPr>
-          <p:cNvPr id="8" name="TextBox 7">
-            <a:extLst>
-              <a:ext uri="{FF2B5EF4-FFF2-40B4-BE49-F238E27FC236}">
-                <a16:creationId xmlns:a16="http://schemas.microsoft.com/office/drawing/2014/main" id="{C02C42FA-D19F-3E1A-4385-361C1AE5B3B6}"/>
-              </a:ext>
-            </a:extLst>
-          </p:cNvPr>
-          <p:cNvSpPr txBox="1"/>
-          <p:nvPr/>
-        </p:nvSpPr>
-        <p:spPr>
-          <a:xfrm>
-            <a:off x="5652935" y="1760255"/>
-            <a:ext cx="5998291" cy="415498"/>
-          </a:xfrm>
-          <a:prstGeom prst="rect">
-            <a:avLst/>
-          </a:prstGeom>
-          <a:noFill/>
-        </p:spPr>
-        <p:txBody>
-          <a:bodyPr wrap="square" lIns="0" tIns="0" rIns="0" bIns="0" anchor="t">
-            <a:spAutoFit/>
-          </a:bodyPr>
-          <a:lstStyle/>
-          <a:p>
-            <a:pPr algn="ctr"/>
-            <a:r>
-              <a:rPr lang="en-GB" sz="2700" b="1" i="0" u="none" dirty="0">
-                <a:solidFill>
-                  <a:srgbClr val="1E293B"/>
-                </a:solidFill>
-                <a:latin typeface="Poppins"/>
-              </a:rPr>
-              <a:t>{{MEANING}}</a:t>
-            </a:r>
-            <a:endParaRPr sz="2700" b="1" i="0" u="none" dirty="0">
-              <a:solidFill>
-                <a:srgbClr val="1E293B"/>
-              </a:solidFill>
-              <a:latin typeface="Poppins"/>
-            </a:endParaRPr>
-          </a:p>
-        </p:txBody>
-      </p:sp>
       <p:pic>
         <p:nvPicPr>
           <p:cNvPr id="11" name="Picture 10">
@@ -4217,10 +4054,10 @@
       </p:pic>
       <p:sp>
         <p:nvSpPr>
-          <p:cNvPr id="12" name="TextBox 11">
+          <p:cNvPr id="10" name="TextBox 9">
             <a:extLst>
               <a:ext uri="{FF2B5EF4-FFF2-40B4-BE49-F238E27FC236}">
-                <a16:creationId xmlns:a16="http://schemas.microsoft.com/office/drawing/2014/main" id="{F75E7494-AA8E-47C6-92B3-0998CFE885EB}"/>
+                <a16:creationId xmlns:a16="http://schemas.microsoft.com/office/drawing/2014/main" id="{BA6C92D8-B625-9D83-E207-CF54C1744E87}"/>
               </a:ext>
             </a:extLst>
           </p:cNvPr>
@@ -4229,7 +4066,170 @@
         </p:nvSpPr>
         <p:spPr>
           <a:xfrm>
-            <a:off x="4889704" y="2457390"/>
+            <a:off x="5515897" y="213702"/>
+            <a:ext cx="6517097" cy="1171475"/>
+          </a:xfrm>
+          <a:prstGeom prst="rect">
+            <a:avLst/>
+          </a:prstGeom>
+          <a:noFill/>
+        </p:spPr>
+        <p:txBody>
+          <a:bodyPr wrap="square" lIns="0" tIns="0" rIns="0" bIns="0" anchor="t">
+            <a:spAutoFit/>
+          </a:bodyPr>
+          <a:lstStyle/>
+          <a:p>
+            <a:pPr algn="ctr">
+              <a:lnSpc>
+                <a:spcPts val="9075"/>
+              </a:lnSpc>
+            </a:pPr>
+            <a:r>
+              <a:rPr lang="en-GB" sz="7400" b="0" i="0" u="none" dirty="0">
+                <a:solidFill>
+                  <a:srgbClr val="0F172A"/>
+                </a:solidFill>
+                <a:latin typeface="Poppins ExtraBold"/>
+              </a:rPr>
+              <a:t>{{WORD}}</a:t>
+            </a:r>
+            <a:endParaRPr sz="7400" b="0" i="0" u="none" dirty="0">
+              <a:solidFill>
+                <a:srgbClr val="0F172A"/>
+              </a:solidFill>
+              <a:latin typeface="Poppins ExtraBold"/>
+            </a:endParaRPr>
+          </a:p>
+        </p:txBody>
+      </p:sp>
+      <p:sp>
+        <p:nvSpPr>
+          <p:cNvPr id="20" name="TextBox 19">
+            <a:extLst>
+              <a:ext uri="{FF2B5EF4-FFF2-40B4-BE49-F238E27FC236}">
+                <a16:creationId xmlns:a16="http://schemas.microsoft.com/office/drawing/2014/main" id="{AB14FDC0-96B5-11CD-CFED-2E1D12F118E6}"/>
+              </a:ext>
+            </a:extLst>
+          </p:cNvPr>
+          <p:cNvSpPr txBox="1"/>
+          <p:nvPr/>
+        </p:nvSpPr>
+        <p:spPr>
+          <a:xfrm>
+            <a:off x="7277098" y="1318246"/>
+            <a:ext cx="2838451" cy="253916"/>
+          </a:xfrm>
+          <a:prstGeom prst="rect">
+            <a:avLst/>
+          </a:prstGeom>
+          <a:noFill/>
+        </p:spPr>
+        <p:txBody>
+          <a:bodyPr wrap="square" lIns="0" tIns="0" rIns="0" bIns="0" anchor="ctr">
+            <a:spAutoFit/>
+          </a:bodyPr>
+          <a:lstStyle/>
+          <a:p>
+            <a:pPr algn="ctr"/>
+            <a:r>
+              <a:rPr lang="en-GB" sz="1650" u="none" dirty="0">
+                <a:solidFill>
+                  <a:srgbClr val="472D33"/>
+                </a:solidFill>
+                <a:latin typeface="Poppins ExtraBold"/>
+              </a:rPr>
+              <a:t>{{</a:t>
+            </a:r>
+            <a:r>
+              <a:rPr lang="en-GB" sz="1400" dirty="0">
+                <a:solidFill>
+                  <a:srgbClr val="472D33"/>
+                </a:solidFill>
+                <a:latin typeface="Poppins ExtraBold"/>
+              </a:rPr>
+              <a:t>PRONUNCIATION</a:t>
+            </a:r>
+            <a:r>
+              <a:rPr lang="en-GB" sz="1650" u="none" dirty="0">
+                <a:solidFill>
+                  <a:srgbClr val="472D33"/>
+                </a:solidFill>
+                <a:latin typeface="Poppins ExtraBold"/>
+              </a:rPr>
+              <a:t>}}</a:t>
+            </a:r>
+            <a:endParaRPr sz="1650" u="none" dirty="0">
+              <a:solidFill>
+                <a:srgbClr val="472D33"/>
+              </a:solidFill>
+              <a:latin typeface="Poppins ExtraBold"/>
+            </a:endParaRPr>
+          </a:p>
+        </p:txBody>
+      </p:sp>
+      <p:sp>
+        <p:nvSpPr>
+          <p:cNvPr id="22" name="TextBox 21">
+            <a:extLst>
+              <a:ext uri="{FF2B5EF4-FFF2-40B4-BE49-F238E27FC236}">
+                <a16:creationId xmlns:a16="http://schemas.microsoft.com/office/drawing/2014/main" id="{0DAA01F0-CDA5-2E9A-FC35-BB3583E37F53}"/>
+              </a:ext>
+            </a:extLst>
+          </p:cNvPr>
+          <p:cNvSpPr txBox="1"/>
+          <p:nvPr/>
+        </p:nvSpPr>
+        <p:spPr>
+          <a:xfrm>
+            <a:off x="5697178" y="1633750"/>
+            <a:ext cx="5998291" cy="415498"/>
+          </a:xfrm>
+          <a:prstGeom prst="rect">
+            <a:avLst/>
+          </a:prstGeom>
+          <a:noFill/>
+        </p:spPr>
+        <p:txBody>
+          <a:bodyPr wrap="square" lIns="0" tIns="0" rIns="0" bIns="0" anchor="t">
+            <a:spAutoFit/>
+          </a:bodyPr>
+          <a:lstStyle/>
+          <a:p>
+            <a:pPr algn="ctr"/>
+            <a:r>
+              <a:rPr lang="en-GB" sz="2700" b="1" i="0" u="none" dirty="0">
+                <a:solidFill>
+                  <a:srgbClr val="1E293B"/>
+                </a:solidFill>
+                <a:latin typeface="Poppins"/>
+              </a:rPr>
+              <a:t>{{MEANING}}</a:t>
+            </a:r>
+            <a:endParaRPr sz="2700" b="1" i="0" u="none" dirty="0">
+              <a:solidFill>
+                <a:srgbClr val="1E293B"/>
+              </a:solidFill>
+              <a:latin typeface="Poppins"/>
+            </a:endParaRPr>
+          </a:p>
+        </p:txBody>
+      </p:sp>
+      <p:sp>
+        <p:nvSpPr>
+          <p:cNvPr id="24" name="TextBox 23">
+            <a:extLst>
+              <a:ext uri="{FF2B5EF4-FFF2-40B4-BE49-F238E27FC236}">
+                <a16:creationId xmlns:a16="http://schemas.microsoft.com/office/drawing/2014/main" id="{7CF2757C-E786-9920-5B44-D58460533C42}"/>
+              </a:ext>
+            </a:extLst>
+          </p:cNvPr>
+          <p:cNvSpPr txBox="1"/>
+          <p:nvPr/>
+        </p:nvSpPr>
+        <p:spPr>
+          <a:xfrm>
+            <a:off x="4889704" y="2526335"/>
             <a:ext cx="3806620" cy="1107996"/>
           </a:xfrm>
           <a:prstGeom prst="rect">
@@ -4484,104 +4484,6 @@
           </a:prstGeom>
         </p:spPr>
       </p:pic>
-      <p:sp>
-        <p:nvSpPr>
-          <p:cNvPr id="7" name="TextBox 6">
-            <a:extLst>
-              <a:ext uri="{FF2B5EF4-FFF2-40B4-BE49-F238E27FC236}">
-                <a16:creationId xmlns:a16="http://schemas.microsoft.com/office/drawing/2014/main" id="{CD94D832-421C-0BB8-B4EF-2E8C316DDE03}"/>
-              </a:ext>
-            </a:extLst>
-          </p:cNvPr>
-          <p:cNvSpPr txBox="1"/>
-          <p:nvPr/>
-        </p:nvSpPr>
-        <p:spPr>
-          <a:xfrm>
-            <a:off x="5869858" y="380999"/>
-            <a:ext cx="5781368" cy="1171475"/>
-          </a:xfrm>
-          <a:prstGeom prst="rect">
-            <a:avLst/>
-          </a:prstGeom>
-          <a:noFill/>
-        </p:spPr>
-        <p:txBody>
-          <a:bodyPr wrap="square" lIns="0" tIns="0" rIns="0" bIns="0" anchor="t">
-            <a:spAutoFit/>
-          </a:bodyPr>
-          <a:lstStyle/>
-          <a:p>
-            <a:pPr algn="ctr">
-              <a:lnSpc>
-                <a:spcPts val="9075"/>
-              </a:lnSpc>
-            </a:pPr>
-            <a:r>
-              <a:rPr lang="en-GB" sz="7400" b="0" i="0" u="none" dirty="0">
-                <a:solidFill>
-                  <a:srgbClr val="0F172A"/>
-                </a:solidFill>
-                <a:latin typeface="Poppins ExtraBold"/>
-              </a:rPr>
-              <a:t>{{WORD}}</a:t>
-            </a:r>
-            <a:endParaRPr sz="7400" b="0" i="0" u="none" dirty="0">
-              <a:solidFill>
-                <a:srgbClr val="0F172A"/>
-              </a:solidFill>
-              <a:latin typeface="Poppins ExtraBold"/>
-            </a:endParaRPr>
-          </a:p>
-        </p:txBody>
-      </p:sp>
-      <p:sp>
-        <p:nvSpPr>
-          <p:cNvPr id="8" name="TextBox 7">
-            <a:extLst>
-              <a:ext uri="{FF2B5EF4-FFF2-40B4-BE49-F238E27FC236}">
-                <a16:creationId xmlns:a16="http://schemas.microsoft.com/office/drawing/2014/main" id="{FA53BDB0-0299-1C06-2767-B086D47E946D}"/>
-              </a:ext>
-            </a:extLst>
-          </p:cNvPr>
-          <p:cNvSpPr txBox="1"/>
-          <p:nvPr/>
-        </p:nvSpPr>
-        <p:spPr>
-          <a:xfrm>
-            <a:off x="5652935" y="1760255"/>
-            <a:ext cx="5998291" cy="415498"/>
-          </a:xfrm>
-          <a:prstGeom prst="rect">
-            <a:avLst/>
-          </a:prstGeom>
-          <a:noFill/>
-        </p:spPr>
-        <p:txBody>
-          <a:bodyPr wrap="square" lIns="0" tIns="0" rIns="0" bIns="0" anchor="t">
-            <a:spAutoFit/>
-          </a:bodyPr>
-          <a:lstStyle/>
-          <a:p>
-            <a:pPr algn="ctr"/>
-            <a:r>
-              <a:rPr lang="en-GB" sz="2700" b="1" i="0" u="none" dirty="0">
-                <a:solidFill>
-                  <a:srgbClr val="1E293B"/>
-                </a:solidFill>
-                <a:latin typeface="Poppins"/>
-              </a:rPr>
-              <a:t>{{MEANING}}</a:t>
-            </a:r>
-            <a:endParaRPr sz="2700" b="1" i="0" u="none" dirty="0">
-              <a:solidFill>
-                <a:srgbClr val="1E293B"/>
-              </a:solidFill>
-              <a:latin typeface="Poppins"/>
-            </a:endParaRPr>
-          </a:p>
-        </p:txBody>
-      </p:sp>
       <p:pic>
         <p:nvPicPr>
           <p:cNvPr id="11" name="Picture 10">
@@ -4892,71 +4794,6 @@
           </a:p>
         </p:txBody>
       </p:sp>
-      <p:sp>
-        <p:nvSpPr>
-          <p:cNvPr id="25" name="TextBox 24">
-            <a:extLst>
-              <a:ext uri="{FF2B5EF4-FFF2-40B4-BE49-F238E27FC236}">
-                <a16:creationId xmlns:a16="http://schemas.microsoft.com/office/drawing/2014/main" id="{4D793BF9-6668-B68C-6469-0785C86AA080}"/>
-              </a:ext>
-            </a:extLst>
-          </p:cNvPr>
-          <p:cNvSpPr txBox="1"/>
-          <p:nvPr/>
-        </p:nvSpPr>
-        <p:spPr>
-          <a:xfrm>
-            <a:off x="7277098" y="1425516"/>
-            <a:ext cx="2838451" cy="253916"/>
-          </a:xfrm>
-          <a:prstGeom prst="rect">
-            <a:avLst/>
-          </a:prstGeom>
-          <a:noFill/>
-        </p:spPr>
-        <p:txBody>
-          <a:bodyPr wrap="square" lIns="0" tIns="0" rIns="0" bIns="0" anchor="ctr">
-            <a:spAutoFit/>
-          </a:bodyPr>
-          <a:lstStyle/>
-          <a:p>
-            <a:pPr algn="ctr"/>
-            <a:r>
-              <a:rPr lang="en-GB" sz="1650" u="none" dirty="0">
-                <a:solidFill>
-                  <a:srgbClr val="472D33"/>
-                </a:solidFill>
-                <a:latin typeface="Poppins ExtraBold"/>
-              </a:rPr>
-              <a:t>{{</a:t>
-            </a:r>
-            <a:r>
-              <a:rPr lang="en-GB" sz="1400" dirty="0">
-                <a:solidFill>
-                  <a:srgbClr val="472D33"/>
-                </a:solidFill>
-                <a:latin typeface="Poppins ExtraBold"/>
-              </a:rPr>
-              <a:t>PRONUNCIATION</a:t>
-            </a:r>
-            <a:r>
-              <a:rPr lang="en-GB" sz="1650" u="none" dirty="0">
-                <a:solidFill>
-                  <a:srgbClr val="472D33"/>
-                </a:solidFill>
-                <a:latin typeface="Poppins ExtraBold"/>
-              </a:rPr>
-              <a:t>}}</a:t>
-            </a:r>
-            <a:endParaRPr sz="1650" u="none" dirty="0">
-              <a:solidFill>
-                <a:srgbClr val="472D33"/>
-              </a:solidFill>
-              <a:latin typeface="Poppins ExtraBold"/>
-            </a:endParaRPr>
-          </a:p>
-        </p:txBody>
-      </p:sp>
       <p:pic>
         <p:nvPicPr>
           <p:cNvPr id="4" name="VOCAB_IMAGE" descr="image.png">
@@ -4989,10 +4826,10 @@
       </p:pic>
       <p:sp>
         <p:nvSpPr>
-          <p:cNvPr id="9" name="TextBox 8">
+          <p:cNvPr id="6" name="TextBox 5">
             <a:extLst>
               <a:ext uri="{FF2B5EF4-FFF2-40B4-BE49-F238E27FC236}">
-                <a16:creationId xmlns:a16="http://schemas.microsoft.com/office/drawing/2014/main" id="{42C33F70-C76D-DCCC-A106-5AB88D4753B0}"/>
+                <a16:creationId xmlns:a16="http://schemas.microsoft.com/office/drawing/2014/main" id="{E1D5E0B8-1969-5150-7E87-49689D59AFBF}"/>
               </a:ext>
             </a:extLst>
           </p:cNvPr>
@@ -5001,7 +4838,170 @@
         </p:nvSpPr>
         <p:spPr>
           <a:xfrm>
-            <a:off x="4889704" y="2457390"/>
+            <a:off x="5515897" y="213702"/>
+            <a:ext cx="6517097" cy="1171475"/>
+          </a:xfrm>
+          <a:prstGeom prst="rect">
+            <a:avLst/>
+          </a:prstGeom>
+          <a:noFill/>
+        </p:spPr>
+        <p:txBody>
+          <a:bodyPr wrap="square" lIns="0" tIns="0" rIns="0" bIns="0" anchor="t">
+            <a:spAutoFit/>
+          </a:bodyPr>
+          <a:lstStyle/>
+          <a:p>
+            <a:pPr algn="ctr">
+              <a:lnSpc>
+                <a:spcPts val="9075"/>
+              </a:lnSpc>
+            </a:pPr>
+            <a:r>
+              <a:rPr lang="en-GB" sz="7400" b="0" i="0" u="none" dirty="0">
+                <a:solidFill>
+                  <a:srgbClr val="0F172A"/>
+                </a:solidFill>
+                <a:latin typeface="Poppins ExtraBold"/>
+              </a:rPr>
+              <a:t>{{WORD}}</a:t>
+            </a:r>
+            <a:endParaRPr sz="7400" b="0" i="0" u="none" dirty="0">
+              <a:solidFill>
+                <a:srgbClr val="0F172A"/>
+              </a:solidFill>
+              <a:latin typeface="Poppins ExtraBold"/>
+            </a:endParaRPr>
+          </a:p>
+        </p:txBody>
+      </p:sp>
+      <p:sp>
+        <p:nvSpPr>
+          <p:cNvPr id="12" name="TextBox 11">
+            <a:extLst>
+              <a:ext uri="{FF2B5EF4-FFF2-40B4-BE49-F238E27FC236}">
+                <a16:creationId xmlns:a16="http://schemas.microsoft.com/office/drawing/2014/main" id="{4CD9D482-6922-BBCD-7870-A2F266791D4D}"/>
+              </a:ext>
+            </a:extLst>
+          </p:cNvPr>
+          <p:cNvSpPr txBox="1"/>
+          <p:nvPr/>
+        </p:nvSpPr>
+        <p:spPr>
+          <a:xfrm>
+            <a:off x="7277098" y="1318246"/>
+            <a:ext cx="2838451" cy="253916"/>
+          </a:xfrm>
+          <a:prstGeom prst="rect">
+            <a:avLst/>
+          </a:prstGeom>
+          <a:noFill/>
+        </p:spPr>
+        <p:txBody>
+          <a:bodyPr wrap="square" lIns="0" tIns="0" rIns="0" bIns="0" anchor="ctr">
+            <a:spAutoFit/>
+          </a:bodyPr>
+          <a:lstStyle/>
+          <a:p>
+            <a:pPr algn="ctr"/>
+            <a:r>
+              <a:rPr lang="en-GB" sz="1650" u="none" dirty="0">
+                <a:solidFill>
+                  <a:srgbClr val="472D33"/>
+                </a:solidFill>
+                <a:latin typeface="Poppins ExtraBold"/>
+              </a:rPr>
+              <a:t>{{</a:t>
+            </a:r>
+            <a:r>
+              <a:rPr lang="en-GB" sz="1400" dirty="0">
+                <a:solidFill>
+                  <a:srgbClr val="472D33"/>
+                </a:solidFill>
+                <a:latin typeface="Poppins ExtraBold"/>
+              </a:rPr>
+              <a:t>PRONUNCIATION</a:t>
+            </a:r>
+            <a:r>
+              <a:rPr lang="en-GB" sz="1650" u="none" dirty="0">
+                <a:solidFill>
+                  <a:srgbClr val="472D33"/>
+                </a:solidFill>
+                <a:latin typeface="Poppins ExtraBold"/>
+              </a:rPr>
+              <a:t>}}</a:t>
+            </a:r>
+            <a:endParaRPr sz="1650" u="none" dirty="0">
+              <a:solidFill>
+                <a:srgbClr val="472D33"/>
+              </a:solidFill>
+              <a:latin typeface="Poppins ExtraBold"/>
+            </a:endParaRPr>
+          </a:p>
+        </p:txBody>
+      </p:sp>
+      <p:sp>
+        <p:nvSpPr>
+          <p:cNvPr id="15" name="TextBox 14">
+            <a:extLst>
+              <a:ext uri="{FF2B5EF4-FFF2-40B4-BE49-F238E27FC236}">
+                <a16:creationId xmlns:a16="http://schemas.microsoft.com/office/drawing/2014/main" id="{13F5471F-F28D-66C0-3F0E-95BE45FDA550}"/>
+              </a:ext>
+            </a:extLst>
+          </p:cNvPr>
+          <p:cNvSpPr txBox="1"/>
+          <p:nvPr/>
+        </p:nvSpPr>
+        <p:spPr>
+          <a:xfrm>
+            <a:off x="5697178" y="1633750"/>
+            <a:ext cx="5998291" cy="415498"/>
+          </a:xfrm>
+          <a:prstGeom prst="rect">
+            <a:avLst/>
+          </a:prstGeom>
+          <a:noFill/>
+        </p:spPr>
+        <p:txBody>
+          <a:bodyPr wrap="square" lIns="0" tIns="0" rIns="0" bIns="0" anchor="t">
+            <a:spAutoFit/>
+          </a:bodyPr>
+          <a:lstStyle/>
+          <a:p>
+            <a:pPr algn="ctr"/>
+            <a:r>
+              <a:rPr lang="en-GB" sz="2700" b="1" i="0" u="none" dirty="0">
+                <a:solidFill>
+                  <a:srgbClr val="1E293B"/>
+                </a:solidFill>
+                <a:latin typeface="Poppins"/>
+              </a:rPr>
+              <a:t>{{MEANING}}</a:t>
+            </a:r>
+            <a:endParaRPr sz="2700" b="1" i="0" u="none" dirty="0">
+              <a:solidFill>
+                <a:srgbClr val="1E293B"/>
+              </a:solidFill>
+              <a:latin typeface="Poppins"/>
+            </a:endParaRPr>
+          </a:p>
+        </p:txBody>
+      </p:sp>
+      <p:sp>
+        <p:nvSpPr>
+          <p:cNvPr id="18" name="TextBox 17">
+            <a:extLst>
+              <a:ext uri="{FF2B5EF4-FFF2-40B4-BE49-F238E27FC236}">
+                <a16:creationId xmlns:a16="http://schemas.microsoft.com/office/drawing/2014/main" id="{217DFD58-B561-E5FE-24B6-1ECFF848EE60}"/>
+              </a:ext>
+            </a:extLst>
+          </p:cNvPr>
+          <p:cNvSpPr txBox="1"/>
+          <p:nvPr/>
+        </p:nvSpPr>
+        <p:spPr>
+          <a:xfrm>
+            <a:off x="4889704" y="2526335"/>
             <a:ext cx="3806620" cy="1107996"/>
           </a:xfrm>
           <a:prstGeom prst="rect">
@@ -5256,104 +5256,6 @@
           </a:prstGeom>
         </p:spPr>
       </p:pic>
-      <p:sp>
-        <p:nvSpPr>
-          <p:cNvPr id="7" name="TextBox 6">
-            <a:extLst>
-              <a:ext uri="{FF2B5EF4-FFF2-40B4-BE49-F238E27FC236}">
-                <a16:creationId xmlns:a16="http://schemas.microsoft.com/office/drawing/2014/main" id="{AE19242B-B8EF-E742-6363-D66D6E904EA3}"/>
-              </a:ext>
-            </a:extLst>
-          </p:cNvPr>
-          <p:cNvSpPr txBox="1"/>
-          <p:nvPr/>
-        </p:nvSpPr>
-        <p:spPr>
-          <a:xfrm>
-            <a:off x="5869858" y="380999"/>
-            <a:ext cx="5781368" cy="1171475"/>
-          </a:xfrm>
-          <a:prstGeom prst="rect">
-            <a:avLst/>
-          </a:prstGeom>
-          <a:noFill/>
-        </p:spPr>
-        <p:txBody>
-          <a:bodyPr wrap="square" lIns="0" tIns="0" rIns="0" bIns="0" anchor="t">
-            <a:spAutoFit/>
-          </a:bodyPr>
-          <a:lstStyle/>
-          <a:p>
-            <a:pPr algn="ctr">
-              <a:lnSpc>
-                <a:spcPts val="9075"/>
-              </a:lnSpc>
-            </a:pPr>
-            <a:r>
-              <a:rPr lang="en-GB" sz="7400" b="0" i="0" u="none" dirty="0">
-                <a:solidFill>
-                  <a:srgbClr val="0F172A"/>
-                </a:solidFill>
-                <a:latin typeface="Poppins ExtraBold"/>
-              </a:rPr>
-              <a:t>{{WORD}}</a:t>
-            </a:r>
-            <a:endParaRPr sz="7400" b="0" i="0" u="none" dirty="0">
-              <a:solidFill>
-                <a:srgbClr val="0F172A"/>
-              </a:solidFill>
-              <a:latin typeface="Poppins ExtraBold"/>
-            </a:endParaRPr>
-          </a:p>
-        </p:txBody>
-      </p:sp>
-      <p:sp>
-        <p:nvSpPr>
-          <p:cNvPr id="8" name="TextBox 7">
-            <a:extLst>
-              <a:ext uri="{FF2B5EF4-FFF2-40B4-BE49-F238E27FC236}">
-                <a16:creationId xmlns:a16="http://schemas.microsoft.com/office/drawing/2014/main" id="{F9FA01F0-8011-B7A8-5886-E85AF764AA61}"/>
-              </a:ext>
-            </a:extLst>
-          </p:cNvPr>
-          <p:cNvSpPr txBox="1"/>
-          <p:nvPr/>
-        </p:nvSpPr>
-        <p:spPr>
-          <a:xfrm>
-            <a:off x="5652935" y="1760255"/>
-            <a:ext cx="5998291" cy="415498"/>
-          </a:xfrm>
-          <a:prstGeom prst="rect">
-            <a:avLst/>
-          </a:prstGeom>
-          <a:noFill/>
-        </p:spPr>
-        <p:txBody>
-          <a:bodyPr wrap="square" lIns="0" tIns="0" rIns="0" bIns="0" anchor="t">
-            <a:spAutoFit/>
-          </a:bodyPr>
-          <a:lstStyle/>
-          <a:p>
-            <a:pPr algn="ctr"/>
-            <a:r>
-              <a:rPr lang="en-GB" sz="2700" b="1" i="0" u="none" dirty="0">
-                <a:solidFill>
-                  <a:srgbClr val="1E293B"/>
-                </a:solidFill>
-                <a:latin typeface="Poppins"/>
-              </a:rPr>
-              <a:t>{{MEANING}}</a:t>
-            </a:r>
-            <a:endParaRPr sz="2700" b="1" i="0" u="none" dirty="0">
-              <a:solidFill>
-                <a:srgbClr val="1E293B"/>
-              </a:solidFill>
-              <a:latin typeface="Poppins"/>
-            </a:endParaRPr>
-          </a:p>
-        </p:txBody>
-      </p:sp>
       <p:pic>
         <p:nvPicPr>
           <p:cNvPr id="11" name="Picture 10">
@@ -5411,7 +5313,7 @@
         <p:spPr>
           <a:xfrm>
             <a:off x="2630128" y="5984803"/>
-            <a:ext cx="7560085" cy="369332"/>
+            <a:ext cx="8240048" cy="369332"/>
           </a:xfrm>
           <a:prstGeom prst="rect">
             <a:avLst/>
@@ -5676,71 +5578,6 @@
             <a:endParaRPr sz="2400" b="0" i="0" u="none" dirty="0">
               <a:solidFill>
                 <a:srgbClr val="2A3644"/>
-              </a:solidFill>
-              <a:latin typeface="Poppins ExtraBold"/>
-            </a:endParaRPr>
-          </a:p>
-        </p:txBody>
-      </p:sp>
-      <p:sp>
-        <p:nvSpPr>
-          <p:cNvPr id="32" name="TextBox 31">
-            <a:extLst>
-              <a:ext uri="{FF2B5EF4-FFF2-40B4-BE49-F238E27FC236}">
-                <a16:creationId xmlns:a16="http://schemas.microsoft.com/office/drawing/2014/main" id="{DE2C92EE-F42D-1CE7-8EE0-7AE90461F18C}"/>
-              </a:ext>
-            </a:extLst>
-          </p:cNvPr>
-          <p:cNvSpPr txBox="1"/>
-          <p:nvPr/>
-        </p:nvSpPr>
-        <p:spPr>
-          <a:xfrm>
-            <a:off x="7277098" y="1425516"/>
-            <a:ext cx="2838451" cy="253916"/>
-          </a:xfrm>
-          <a:prstGeom prst="rect">
-            <a:avLst/>
-          </a:prstGeom>
-          <a:noFill/>
-        </p:spPr>
-        <p:txBody>
-          <a:bodyPr wrap="square" lIns="0" tIns="0" rIns="0" bIns="0" anchor="ctr">
-            <a:spAutoFit/>
-          </a:bodyPr>
-          <a:lstStyle/>
-          <a:p>
-            <a:pPr algn="ctr"/>
-            <a:r>
-              <a:rPr lang="en-GB" sz="1650" u="none" dirty="0">
-                <a:solidFill>
-                  <a:srgbClr val="472D33"/>
-                </a:solidFill>
-                <a:latin typeface="Poppins ExtraBold"/>
-              </a:rPr>
-              <a:t>{{</a:t>
-            </a:r>
-            <a:r>
-              <a:rPr lang="en-GB" sz="1400" dirty="0">
-                <a:solidFill>
-                  <a:srgbClr val="472D33"/>
-                </a:solidFill>
-                <a:latin typeface="Poppins ExtraBold"/>
-              </a:rPr>
-              <a:t>PRONUNCIATION</a:t>
-            </a:r>
-            <a:r>
-              <a:rPr lang="en-GB" sz="1650" u="none" dirty="0">
-                <a:solidFill>
-                  <a:srgbClr val="472D33"/>
-                </a:solidFill>
-                <a:latin typeface="Poppins ExtraBold"/>
-              </a:rPr>
-              <a:t>}}</a:t>
-            </a:r>
-            <a:endParaRPr sz="1650" u="none" dirty="0">
-              <a:solidFill>
-                <a:srgbClr val="472D33"/>
               </a:solidFill>
               <a:latin typeface="Poppins ExtraBold"/>
             </a:endParaRPr>
@@ -5779,171 +5616,6 @@
       </p:pic>
       <p:sp>
         <p:nvSpPr>
-          <p:cNvPr id="9" name="TextBox 8">
-            <a:extLst>
-              <a:ext uri="{FF2B5EF4-FFF2-40B4-BE49-F238E27FC236}">
-                <a16:creationId xmlns:a16="http://schemas.microsoft.com/office/drawing/2014/main" id="{DE46360C-C842-CACE-C3FF-8EBF6C160A9D}"/>
-              </a:ext>
-            </a:extLst>
-          </p:cNvPr>
-          <p:cNvSpPr txBox="1"/>
-          <p:nvPr/>
-        </p:nvSpPr>
-        <p:spPr>
-          <a:xfrm>
-            <a:off x="4889704" y="2457390"/>
-            <a:ext cx="3806620" cy="1107996"/>
-          </a:xfrm>
-          <a:prstGeom prst="rect">
-            <a:avLst/>
-          </a:prstGeom>
-          <a:noFill/>
-        </p:spPr>
-        <p:txBody>
-          <a:bodyPr wrap="square" lIns="0" tIns="0" rIns="0" bIns="0" anchor="t">
-            <a:spAutoFit/>
-          </a:bodyPr>
-          <a:lstStyle/>
-          <a:p>
-            <a:pPr algn="ctr"/>
-            <a:r>
-              <a:rPr lang="en-GB" sz="2400" b="0" i="0" u="none" dirty="0">
-                <a:solidFill>
-                  <a:srgbClr val="475569"/>
-                </a:solidFill>
-                <a:latin typeface="Noto Sans SemiBold"/>
-              </a:rPr>
-              <a:t>{{</a:t>
-            </a:r>
-            <a:r>
-              <a:rPr lang="en-GB" sz="2400" dirty="0">
-                <a:solidFill>
-                  <a:srgbClr val="475569"/>
-                </a:solidFill>
-                <a:latin typeface="Noto Sans SemiBold"/>
-              </a:rPr>
-              <a:t>HINDI</a:t>
-            </a:r>
-            <a:r>
-              <a:rPr lang="en-GB" sz="2400" b="0" i="0" u="none" dirty="0">
-                <a:solidFill>
-                  <a:srgbClr val="475569"/>
-                </a:solidFill>
-                <a:latin typeface="Noto Sans SemiBold"/>
-              </a:rPr>
-              <a:t>}}</a:t>
-            </a:r>
-            <a:r>
-              <a:rPr sz="2400" b="0" i="0" u="none" dirty="0">
-                <a:solidFill>
-                  <a:srgbClr val="475569"/>
-                </a:solidFill>
-                <a:latin typeface="Noto Sans SemiBold"/>
-              </a:rPr>
-              <a:t>,</a:t>
-            </a:r>
-            <a:r>
-              <a:rPr dirty="0"/>
-              <a:t>
-</a:t>
-            </a:r>
-            <a:r>
-              <a:rPr sz="2400" b="0" i="0" u="none" dirty="0">
-                <a:solidFill>
-                  <a:srgbClr val="475569"/>
-                </a:solidFill>
-                <a:latin typeface="Noto Sans SemiBold"/>
-              </a:rPr>
-              <a:t> </a:t>
-            </a:r>
-            <a:r>
-              <a:rPr lang="en-GB" sz="2400" b="0" i="0" u="none" dirty="0">
-                <a:solidFill>
-                  <a:srgbClr val="475569"/>
-                </a:solidFill>
-                <a:latin typeface="Noto Sans SemiBold"/>
-              </a:rPr>
-              <a:t>{{</a:t>
-            </a:r>
-            <a:r>
-              <a:rPr lang="en-GB" sz="2400" dirty="0">
-                <a:solidFill>
-                  <a:srgbClr val="475569"/>
-                </a:solidFill>
-                <a:latin typeface="Noto Sans SemiBold"/>
-              </a:rPr>
-              <a:t>MALAYALAM</a:t>
-            </a:r>
-            <a:r>
-              <a:rPr lang="en-GB" sz="2400" b="0" i="0" u="none" dirty="0">
-                <a:solidFill>
-                  <a:srgbClr val="475569"/>
-                </a:solidFill>
-                <a:latin typeface="Noto Sans SemiBold"/>
-              </a:rPr>
-              <a:t>}}</a:t>
-            </a:r>
-            <a:r>
-              <a:rPr sz="2400" b="0" i="0" u="none" dirty="0">
-                <a:solidFill>
-                  <a:srgbClr val="475569"/>
-                </a:solidFill>
-                <a:latin typeface="Noto Sans SemiBold"/>
-              </a:rPr>
-              <a:t>,</a:t>
-            </a:r>
-            <a:r>
-              <a:rPr dirty="0"/>
-              <a:t>
-</a:t>
-            </a:r>
-            <a:r>
-              <a:rPr sz="2400" b="0" i="0" u="none" dirty="0">
-                <a:solidFill>
-                  <a:srgbClr val="475569"/>
-                </a:solidFill>
-                <a:latin typeface="Noto Sans SemiBold"/>
-              </a:rPr>
-              <a:t> </a:t>
-            </a:r>
-            <a:r>
-              <a:rPr lang="en-GB" sz="2400" b="0" i="0" u="none" dirty="0">
-                <a:solidFill>
-                  <a:srgbClr val="475569"/>
-                </a:solidFill>
-                <a:latin typeface="Noto Sans SemiBold"/>
-              </a:rPr>
-              <a:t>{{</a:t>
-            </a:r>
-            <a:r>
-              <a:rPr lang="en-GB" sz="2400" dirty="0">
-                <a:solidFill>
-                  <a:srgbClr val="475569"/>
-                </a:solidFill>
-                <a:latin typeface="Noto Sans SemiBold"/>
-              </a:rPr>
-              <a:t>TAMIL</a:t>
-            </a:r>
-            <a:r>
-              <a:rPr lang="en-GB" sz="2400" b="0" i="0" u="none" dirty="0">
-                <a:solidFill>
-                  <a:srgbClr val="475569"/>
-                </a:solidFill>
-                <a:latin typeface="Noto Sans SemiBold"/>
-              </a:rPr>
-              <a:t>}}</a:t>
-            </a:r>
-            <a:endParaRPr sz="2400" b="0" i="0" u="none" dirty="0">
-              <a:solidFill>
-                <a:srgbClr val="475569"/>
-              </a:solidFill>
-              <a:latin typeface="Noto Sans SemiBold"/>
-            </a:endParaRPr>
-          </a:p>
-        </p:txBody>
-      </p:sp>
-      <p:sp>
-        <p:nvSpPr>
           <p:cNvPr id="13" name="TextBox 12">
             <a:extLst>
               <a:ext uri="{FF2B5EF4-FFF2-40B4-BE49-F238E27FC236}">
@@ -6002,6 +5674,334 @@
                 <a:srgbClr val="2A3644"/>
               </a:solidFill>
               <a:latin typeface="Poppins ExtraBold"/>
+            </a:endParaRPr>
+          </a:p>
+        </p:txBody>
+      </p:sp>
+      <p:sp>
+        <p:nvSpPr>
+          <p:cNvPr id="6" name="TextBox 5">
+            <a:extLst>
+              <a:ext uri="{FF2B5EF4-FFF2-40B4-BE49-F238E27FC236}">
+                <a16:creationId xmlns:a16="http://schemas.microsoft.com/office/drawing/2014/main" id="{304B2B7D-C7F8-A0DE-390F-3455C7396ED4}"/>
+              </a:ext>
+            </a:extLst>
+          </p:cNvPr>
+          <p:cNvSpPr txBox="1"/>
+          <p:nvPr/>
+        </p:nvSpPr>
+        <p:spPr>
+          <a:xfrm>
+            <a:off x="5515897" y="213702"/>
+            <a:ext cx="6517097" cy="1171475"/>
+          </a:xfrm>
+          <a:prstGeom prst="rect">
+            <a:avLst/>
+          </a:prstGeom>
+          <a:noFill/>
+        </p:spPr>
+        <p:txBody>
+          <a:bodyPr wrap="square" lIns="0" tIns="0" rIns="0" bIns="0" anchor="t">
+            <a:spAutoFit/>
+          </a:bodyPr>
+          <a:lstStyle/>
+          <a:p>
+            <a:pPr algn="ctr">
+              <a:lnSpc>
+                <a:spcPts val="9075"/>
+              </a:lnSpc>
+            </a:pPr>
+            <a:r>
+              <a:rPr lang="en-GB" sz="7400" b="0" i="0" u="none" dirty="0">
+                <a:solidFill>
+                  <a:srgbClr val="0F172A"/>
+                </a:solidFill>
+                <a:latin typeface="Poppins ExtraBold"/>
+              </a:rPr>
+              <a:t>{{WORD}}</a:t>
+            </a:r>
+            <a:endParaRPr sz="7400" b="0" i="0" u="none" dirty="0">
+              <a:solidFill>
+                <a:srgbClr val="0F172A"/>
+              </a:solidFill>
+              <a:latin typeface="Poppins ExtraBold"/>
+            </a:endParaRPr>
+          </a:p>
+        </p:txBody>
+      </p:sp>
+      <p:sp>
+        <p:nvSpPr>
+          <p:cNvPr id="15" name="TextBox 14">
+            <a:extLst>
+              <a:ext uri="{FF2B5EF4-FFF2-40B4-BE49-F238E27FC236}">
+                <a16:creationId xmlns:a16="http://schemas.microsoft.com/office/drawing/2014/main" id="{A597910E-8E8D-2CA3-A434-3288D087C590}"/>
+              </a:ext>
+            </a:extLst>
+          </p:cNvPr>
+          <p:cNvSpPr txBox="1"/>
+          <p:nvPr/>
+        </p:nvSpPr>
+        <p:spPr>
+          <a:xfrm>
+            <a:off x="7277098" y="1318246"/>
+            <a:ext cx="2838451" cy="253916"/>
+          </a:xfrm>
+          <a:prstGeom prst="rect">
+            <a:avLst/>
+          </a:prstGeom>
+          <a:noFill/>
+        </p:spPr>
+        <p:txBody>
+          <a:bodyPr wrap="square" lIns="0" tIns="0" rIns="0" bIns="0" anchor="ctr">
+            <a:spAutoFit/>
+          </a:bodyPr>
+          <a:lstStyle/>
+          <a:p>
+            <a:pPr algn="ctr"/>
+            <a:r>
+              <a:rPr lang="en-GB" sz="1650" u="none" dirty="0">
+                <a:solidFill>
+                  <a:srgbClr val="472D33"/>
+                </a:solidFill>
+                <a:latin typeface="Poppins ExtraBold"/>
+              </a:rPr>
+              <a:t>{{</a:t>
+            </a:r>
+            <a:r>
+              <a:rPr lang="en-GB" sz="1400" dirty="0">
+                <a:solidFill>
+                  <a:srgbClr val="472D33"/>
+                </a:solidFill>
+                <a:latin typeface="Poppins ExtraBold"/>
+              </a:rPr>
+              <a:t>PRONUNCIATION</a:t>
+            </a:r>
+            <a:r>
+              <a:rPr lang="en-GB" sz="1650" u="none" dirty="0">
+                <a:solidFill>
+                  <a:srgbClr val="472D33"/>
+                </a:solidFill>
+                <a:latin typeface="Poppins ExtraBold"/>
+              </a:rPr>
+              <a:t>}}</a:t>
+            </a:r>
+            <a:endParaRPr sz="1650" u="none" dirty="0">
+              <a:solidFill>
+                <a:srgbClr val="472D33"/>
+              </a:solidFill>
+              <a:latin typeface="Poppins ExtraBold"/>
+            </a:endParaRPr>
+          </a:p>
+        </p:txBody>
+      </p:sp>
+      <p:sp>
+        <p:nvSpPr>
+          <p:cNvPr id="17" name="TextBox 16">
+            <a:extLst>
+              <a:ext uri="{FF2B5EF4-FFF2-40B4-BE49-F238E27FC236}">
+                <a16:creationId xmlns:a16="http://schemas.microsoft.com/office/drawing/2014/main" id="{84949B3C-0209-A9C4-8867-0E5336B71BC2}"/>
+              </a:ext>
+            </a:extLst>
+          </p:cNvPr>
+          <p:cNvSpPr txBox="1"/>
+          <p:nvPr/>
+        </p:nvSpPr>
+        <p:spPr>
+          <a:xfrm>
+            <a:off x="5697178" y="1633750"/>
+            <a:ext cx="5998291" cy="415498"/>
+          </a:xfrm>
+          <a:prstGeom prst="rect">
+            <a:avLst/>
+          </a:prstGeom>
+          <a:noFill/>
+        </p:spPr>
+        <p:txBody>
+          <a:bodyPr wrap="square" lIns="0" tIns="0" rIns="0" bIns="0" anchor="t">
+            <a:spAutoFit/>
+          </a:bodyPr>
+          <a:lstStyle/>
+          <a:p>
+            <a:pPr algn="ctr"/>
+            <a:r>
+              <a:rPr lang="en-GB" sz="2700" b="1" i="0" u="none" dirty="0">
+                <a:solidFill>
+                  <a:srgbClr val="1E293B"/>
+                </a:solidFill>
+                <a:latin typeface="Poppins"/>
+              </a:rPr>
+              <a:t>{{MEANING}}</a:t>
+            </a:r>
+            <a:endParaRPr sz="2700" b="1" i="0" u="none" dirty="0">
+              <a:solidFill>
+                <a:srgbClr val="1E293B"/>
+              </a:solidFill>
+              <a:latin typeface="Poppins"/>
+            </a:endParaRPr>
+          </a:p>
+        </p:txBody>
+      </p:sp>
+      <p:sp>
+        <p:nvSpPr>
+          <p:cNvPr id="19" name="TextBox 18">
+            <a:extLst>
+              <a:ext uri="{FF2B5EF4-FFF2-40B4-BE49-F238E27FC236}">
+                <a16:creationId xmlns:a16="http://schemas.microsoft.com/office/drawing/2014/main" id="{EB802CE3-BE68-3275-3CF6-F7AD9F7537BD}"/>
+              </a:ext>
+            </a:extLst>
+          </p:cNvPr>
+          <p:cNvSpPr txBox="1"/>
+          <p:nvPr/>
+        </p:nvSpPr>
+        <p:spPr>
+          <a:xfrm>
+            <a:off x="4889704" y="2526335"/>
+            <a:ext cx="3806620" cy="1107996"/>
+          </a:xfrm>
+          <a:prstGeom prst="rect">
+            <a:avLst/>
+          </a:prstGeom>
+          <a:noFill/>
+        </p:spPr>
+        <p:txBody>
+          <a:bodyPr wrap="square" lIns="0" tIns="0" rIns="0" bIns="0" anchor="t">
+            <a:spAutoFit/>
+          </a:bodyPr>
+          <a:lstStyle/>
+          <a:p>
+            <a:pPr algn="ctr"/>
+            <a:r>
+              <a:rPr lang="en-GB" sz="2400" b="0" i="0" u="none" dirty="0">
+                <a:solidFill>
+                  <a:srgbClr val="475569"/>
+                </a:solidFill>
+                <a:latin typeface="Noto Sans SemiBold"/>
+              </a:rPr>
+              <a:t>{{</a:t>
+            </a:r>
+            <a:r>
+              <a:rPr lang="en-GB" sz="2400" dirty="0">
+                <a:solidFill>
+                  <a:srgbClr val="475569"/>
+                </a:solidFill>
+                <a:latin typeface="Noto Sans SemiBold"/>
+              </a:rPr>
+              <a:t>HINDI</a:t>
+            </a:r>
+            <a:r>
+              <a:rPr lang="en-GB" sz="2400" b="0" i="0" u="none" dirty="0">
+                <a:solidFill>
+                  <a:srgbClr val="475569"/>
+                </a:solidFill>
+                <a:latin typeface="Noto Sans SemiBold"/>
+              </a:rPr>
+              <a:t>}}</a:t>
+            </a:r>
+            <a:r>
+              <a:rPr sz="2400" b="0" i="0" u="none" dirty="0">
+                <a:solidFill>
+                  <a:srgbClr val="475569"/>
+                </a:solidFill>
+                <a:latin typeface="Noto Sans SemiBold"/>
+              </a:rPr>
+              <a:t>,</a:t>
+            </a:r>
+            <a:r>
+              <a:rPr dirty="0"/>
+              <a:t>
+</a:t>
+            </a:r>
+            <a:r>
+              <a:rPr sz="2400" b="0" i="0" u="none" dirty="0">
+                <a:solidFill>
+                  <a:srgbClr val="475569"/>
+                </a:solidFill>
+                <a:latin typeface="Noto Sans SemiBold"/>
+              </a:rPr>
+              <a:t> </a:t>
+            </a:r>
+            <a:r>
+              <a:rPr lang="en-GB" sz="2400" b="0" i="0" u="none" dirty="0">
+                <a:solidFill>
+                  <a:srgbClr val="475569"/>
+                </a:solidFill>
+                <a:latin typeface="Noto Sans SemiBold"/>
+              </a:rPr>
+              <a:t>{{</a:t>
+            </a:r>
+            <a:r>
+              <a:rPr lang="en-GB" sz="2400" dirty="0">
+                <a:solidFill>
+                  <a:srgbClr val="475569"/>
+                </a:solidFill>
+                <a:latin typeface="Noto Sans SemiBold"/>
+              </a:rPr>
+              <a:t>MALAYALAM</a:t>
+            </a:r>
+            <a:r>
+              <a:rPr lang="en-GB" sz="2400" b="0" i="0" u="none" dirty="0">
+                <a:solidFill>
+                  <a:srgbClr val="475569"/>
+                </a:solidFill>
+                <a:latin typeface="Noto Sans SemiBold"/>
+              </a:rPr>
+              <a:t>}}</a:t>
+            </a:r>
+            <a:r>
+              <a:rPr sz="2400" b="0" i="0" u="none" dirty="0">
+                <a:solidFill>
+                  <a:srgbClr val="475569"/>
+                </a:solidFill>
+                <a:latin typeface="Noto Sans SemiBold"/>
+              </a:rPr>
+              <a:t>,</a:t>
+            </a:r>
+            <a:r>
+              <a:rPr dirty="0"/>
+              <a:t>
+</a:t>
+            </a:r>
+            <a:r>
+              <a:rPr sz="2400" b="0" i="0" u="none" dirty="0">
+                <a:solidFill>
+                  <a:srgbClr val="475569"/>
+                </a:solidFill>
+                <a:latin typeface="Noto Sans SemiBold"/>
+              </a:rPr>
+              <a:t> </a:t>
+            </a:r>
+            <a:r>
+              <a:rPr lang="en-GB" sz="2400" b="0" i="0" u="none" dirty="0">
+                <a:solidFill>
+                  <a:srgbClr val="475569"/>
+                </a:solidFill>
+                <a:latin typeface="Noto Sans SemiBold"/>
+              </a:rPr>
+              <a:t>{{</a:t>
+            </a:r>
+            <a:r>
+              <a:rPr lang="en-GB" sz="2400" dirty="0">
+                <a:solidFill>
+                  <a:srgbClr val="475569"/>
+                </a:solidFill>
+                <a:latin typeface="Noto Sans SemiBold"/>
+              </a:rPr>
+              <a:t>TAMIL</a:t>
+            </a:r>
+            <a:r>
+              <a:rPr lang="en-GB" sz="2400" b="0" i="0" u="none" dirty="0">
+                <a:solidFill>
+                  <a:srgbClr val="475569"/>
+                </a:solidFill>
+                <a:latin typeface="Noto Sans SemiBold"/>
+              </a:rPr>
+              <a:t>}}</a:t>
+            </a:r>
+            <a:endParaRPr sz="2400" b="0" i="0" u="none" dirty="0">
+              <a:solidFill>
+                <a:srgbClr val="475569"/>
+              </a:solidFill>
+              <a:latin typeface="Noto Sans SemiBold"/>
             </a:endParaRPr>
           </a:p>
         </p:txBody>

</xml_diff>

<commit_message>
Add dynamic vocabulary progress bar
</commit_message>
<xml_diff>
--- a/templates/vocabulary_template_v3.pptx
+++ b/templates/vocabulary_template_v3.pptx
@@ -3117,7 +3117,7 @@
         </p:blipFill>
         <p:spPr>
           <a:xfrm>
-            <a:off x="0" y="0"/>
+            <a:off x="0" y="5573"/>
             <a:ext cx="12192000" cy="6858000"/>
           </a:xfrm>
           <a:prstGeom prst="rect">
@@ -3224,8 +3224,8 @@
         </p:blipFill>
         <p:spPr>
           <a:xfrm>
-            <a:off x="0" y="7061"/>
-            <a:ext cx="4719484" cy="3550377"/>
+            <a:off x="0" y="0"/>
+            <a:ext cx="4719484" cy="3557439"/>
           </a:xfrm>
           <a:prstGeom prst="rect">
             <a:avLst/>
@@ -3626,7 +3626,7 @@
         </p:nvSpPr>
         <p:spPr>
           <a:xfrm>
-            <a:off x="226314" y="6356494"/>
+            <a:off x="296784" y="6156796"/>
             <a:ext cx="1994105" cy="230832"/>
           </a:xfrm>
           <a:prstGeom prst="rect">
@@ -3674,6 +3674,100 @@
               </a:solidFill>
               <a:latin typeface="Poppins SemiBold"/>
             </a:endParaRPr>
+          </a:p>
+        </p:txBody>
+      </p:sp>
+      <p:sp>
+        <p:nvSpPr>
+          <p:cNvPr id="18" name="PROGRESS_TRACK">
+            <a:extLst>
+              <a:ext uri="{FF2B5EF4-FFF2-40B4-BE49-F238E27FC236}">
+                <a16:creationId xmlns:a16="http://schemas.microsoft.com/office/drawing/2014/main" id="{67AA182C-43CD-6048-8E07-6A697FC9437D}"/>
+              </a:ext>
+            </a:extLst>
+          </p:cNvPr>
+          <p:cNvSpPr/>
+          <p:nvPr/>
+        </p:nvSpPr>
+        <p:spPr>
+          <a:xfrm>
+            <a:off x="553932" y="6507311"/>
+            <a:ext cx="1479807" cy="231006"/>
+          </a:xfrm>
+          <a:prstGeom prst="roundRect">
+            <a:avLst/>
+          </a:prstGeom>
+          <a:solidFill>
+            <a:srgbClr val="E0E0E0"/>
+          </a:solidFill>
+        </p:spPr>
+        <p:style>
+          <a:lnRef idx="1">
+            <a:schemeClr val="accent1"/>
+          </a:lnRef>
+          <a:fillRef idx="3">
+            <a:schemeClr val="accent1"/>
+          </a:fillRef>
+          <a:effectRef idx="2">
+            <a:schemeClr val="accent1"/>
+          </a:effectRef>
+          <a:fontRef idx="minor">
+            <a:schemeClr val="lt1"/>
+          </a:fontRef>
+        </p:style>
+        <p:txBody>
+          <a:bodyPr rtlCol="0" anchor="ctr"/>
+          <a:lstStyle/>
+          <a:p>
+            <a:pPr algn="ctr"/>
+            <a:endParaRPr lang="en-IN" dirty="0"/>
+          </a:p>
+        </p:txBody>
+      </p:sp>
+      <p:sp>
+        <p:nvSpPr>
+          <p:cNvPr id="19" name="PROGRESS_FILL">
+            <a:extLst>
+              <a:ext uri="{FF2B5EF4-FFF2-40B4-BE49-F238E27FC236}">
+                <a16:creationId xmlns:a16="http://schemas.microsoft.com/office/drawing/2014/main" id="{38F9A4D1-30BB-E88B-9CD6-62D31A7F1A80}"/>
+              </a:ext>
+            </a:extLst>
+          </p:cNvPr>
+          <p:cNvSpPr/>
+          <p:nvPr/>
+        </p:nvSpPr>
+        <p:spPr>
+          <a:xfrm>
+            <a:off x="553931" y="6507311"/>
+            <a:ext cx="1479807" cy="231006"/>
+          </a:xfrm>
+          <a:prstGeom prst="roundRect">
+            <a:avLst/>
+          </a:prstGeom>
+          <a:solidFill>
+            <a:srgbClr val="0D6EFD"/>
+          </a:solidFill>
+        </p:spPr>
+        <p:style>
+          <a:lnRef idx="1">
+            <a:schemeClr val="accent1"/>
+          </a:lnRef>
+          <a:fillRef idx="3">
+            <a:schemeClr val="accent1"/>
+          </a:fillRef>
+          <a:effectRef idx="2">
+            <a:schemeClr val="accent1"/>
+          </a:effectRef>
+          <a:fontRef idx="minor">
+            <a:schemeClr val="lt1"/>
+          </a:fontRef>
+        </p:style>
+        <p:txBody>
+          <a:bodyPr rtlCol="0" anchor="ctr"/>
+          <a:lstStyle/>
+          <a:p>
+            <a:pPr algn="ctr"/>
+            <a:endParaRPr lang="en-IN" dirty="0"/>
           </a:p>
         </p:txBody>
       </p:sp>
@@ -3746,71 +3840,6 @@
           </a:prstGeom>
         </p:spPr>
       </p:pic>
-      <p:sp>
-        <p:nvSpPr>
-          <p:cNvPr id="3" name="TextBox 2">
-            <a:extLst>
-              <a:ext uri="{FF2B5EF4-FFF2-40B4-BE49-F238E27FC236}">
-                <a16:creationId xmlns:a16="http://schemas.microsoft.com/office/drawing/2014/main" id="{82A1C92A-00A5-A774-61BC-3DADB71CCAEC}"/>
-              </a:ext>
-            </a:extLst>
-          </p:cNvPr>
-          <p:cNvSpPr txBox="1"/>
-          <p:nvPr/>
-        </p:nvSpPr>
-        <p:spPr>
-          <a:xfrm>
-            <a:off x="226314" y="6356494"/>
-            <a:ext cx="1994105" cy="230832"/>
-          </a:xfrm>
-          <a:prstGeom prst="rect">
-            <a:avLst/>
-          </a:prstGeom>
-          <a:noFill/>
-        </p:spPr>
-        <p:txBody>
-          <a:bodyPr wrap="square" lIns="0" tIns="0" rIns="0" bIns="0" anchor="ctr">
-            <a:spAutoFit/>
-          </a:bodyPr>
-          <a:lstStyle/>
-          <a:p>
-            <a:pPr algn="ctr"/>
-            <a:r>
-              <a:rPr lang="en-GB" sz="1500" b="0" i="0" u="none" dirty="0">
-                <a:solidFill>
-                  <a:srgbClr val="64748B"/>
-                </a:solidFill>
-                <a:latin typeface="Poppins SemiBold"/>
-              </a:rPr>
-              <a:t>{{</a:t>
-            </a:r>
-            <a:r>
-              <a:rPr lang="en-GB" sz="1500" dirty="0">
-                <a:solidFill>
-                  <a:srgbClr val="64748B"/>
-                </a:solidFill>
-                <a:latin typeface="Poppins SemiBold"/>
-              </a:rPr>
-              <a:t>WORD_NUMBER</a:t>
-            </a:r>
-            <a:r>
-              <a:rPr lang="en-GB" sz="1500" b="0" i="0" u="none" dirty="0">
-                <a:solidFill>
-                  <a:srgbClr val="64748B"/>
-                </a:solidFill>
-                <a:latin typeface="Poppins SemiBold"/>
-              </a:rPr>
-              <a:t>}}</a:t>
-            </a:r>
-            <a:endParaRPr sz="1500" b="0" i="0" u="none" dirty="0">
-              <a:solidFill>
-                <a:srgbClr val="2563EB"/>
-              </a:solidFill>
-              <a:latin typeface="Poppins SemiBold"/>
-            </a:endParaRPr>
-          </a:p>
-        </p:txBody>
-      </p:sp>
       <p:pic>
         <p:nvPicPr>
           <p:cNvPr id="5" name="Picture 4" descr="image.png">
@@ -4044,8 +4073,8 @@
         </p:blipFill>
         <p:spPr>
           <a:xfrm>
-            <a:off x="0" y="7061"/>
-            <a:ext cx="4719484" cy="3550377"/>
+            <a:off x="0" y="1"/>
+            <a:ext cx="4719484" cy="3557438"/>
           </a:xfrm>
           <a:prstGeom prst="rect">
             <a:avLst/>
@@ -4377,6 +4406,165 @@
               </a:solidFill>
               <a:latin typeface="Noto Sans SemiBold"/>
             </a:endParaRPr>
+          </a:p>
+        </p:txBody>
+      </p:sp>
+      <p:sp>
+        <p:nvSpPr>
+          <p:cNvPr id="26" name="TextBox 25">
+            <a:extLst>
+              <a:ext uri="{FF2B5EF4-FFF2-40B4-BE49-F238E27FC236}">
+                <a16:creationId xmlns:a16="http://schemas.microsoft.com/office/drawing/2014/main" id="{53EA3E07-4242-96F2-B06B-7167CE3ADE1F}"/>
+              </a:ext>
+            </a:extLst>
+          </p:cNvPr>
+          <p:cNvSpPr txBox="1"/>
+          <p:nvPr/>
+        </p:nvSpPr>
+        <p:spPr>
+          <a:xfrm>
+            <a:off x="296784" y="6156796"/>
+            <a:ext cx="1994105" cy="230832"/>
+          </a:xfrm>
+          <a:prstGeom prst="rect">
+            <a:avLst/>
+          </a:prstGeom>
+          <a:noFill/>
+        </p:spPr>
+        <p:txBody>
+          <a:bodyPr wrap="square" lIns="0" tIns="0" rIns="0" bIns="0" anchor="ctr">
+            <a:spAutoFit/>
+          </a:bodyPr>
+          <a:lstStyle/>
+          <a:p>
+            <a:pPr algn="ctr"/>
+            <a:r>
+              <a:rPr lang="en-GB" sz="1500" b="0" i="0" u="none" dirty="0">
+                <a:solidFill>
+                  <a:srgbClr val="64748B"/>
+                </a:solidFill>
+                <a:latin typeface="Poppins SemiBold"/>
+              </a:rPr>
+              <a:t>{{</a:t>
+            </a:r>
+            <a:r>
+              <a:rPr lang="en-GB" sz="1500" dirty="0">
+                <a:solidFill>
+                  <a:srgbClr val="64748B"/>
+                </a:solidFill>
+                <a:latin typeface="Poppins SemiBold"/>
+              </a:rPr>
+              <a:t>WORD_NUMBER</a:t>
+            </a:r>
+            <a:r>
+              <a:rPr lang="en-GB" sz="1500" b="0" i="0" u="none" dirty="0">
+                <a:solidFill>
+                  <a:srgbClr val="64748B"/>
+                </a:solidFill>
+                <a:latin typeface="Poppins SemiBold"/>
+              </a:rPr>
+              <a:t>}}</a:t>
+            </a:r>
+            <a:endParaRPr sz="1500" b="0" i="0" u="none" dirty="0">
+              <a:solidFill>
+                <a:srgbClr val="2563EB"/>
+              </a:solidFill>
+              <a:latin typeface="Poppins SemiBold"/>
+            </a:endParaRPr>
+          </a:p>
+        </p:txBody>
+      </p:sp>
+      <p:sp>
+        <p:nvSpPr>
+          <p:cNvPr id="30" name="PROGRESS_TRACK">
+            <a:extLst>
+              <a:ext uri="{FF2B5EF4-FFF2-40B4-BE49-F238E27FC236}">
+                <a16:creationId xmlns:a16="http://schemas.microsoft.com/office/drawing/2014/main" id="{CC8B99D7-37DC-D987-22FB-2D85E169B889}"/>
+              </a:ext>
+            </a:extLst>
+          </p:cNvPr>
+          <p:cNvSpPr/>
+          <p:nvPr/>
+        </p:nvSpPr>
+        <p:spPr>
+          <a:xfrm>
+            <a:off x="553932" y="6507311"/>
+            <a:ext cx="1479807" cy="231006"/>
+          </a:xfrm>
+          <a:prstGeom prst="roundRect">
+            <a:avLst/>
+          </a:prstGeom>
+          <a:solidFill>
+            <a:srgbClr val="E0E0E0"/>
+          </a:solidFill>
+        </p:spPr>
+        <p:style>
+          <a:lnRef idx="1">
+            <a:schemeClr val="accent1"/>
+          </a:lnRef>
+          <a:fillRef idx="3">
+            <a:schemeClr val="accent1"/>
+          </a:fillRef>
+          <a:effectRef idx="2">
+            <a:schemeClr val="accent1"/>
+          </a:effectRef>
+          <a:fontRef idx="minor">
+            <a:schemeClr val="lt1"/>
+          </a:fontRef>
+        </p:style>
+        <p:txBody>
+          <a:bodyPr rtlCol="0" anchor="ctr"/>
+          <a:lstStyle/>
+          <a:p>
+            <a:pPr algn="ctr"/>
+            <a:endParaRPr lang="en-IN" dirty="0"/>
+          </a:p>
+        </p:txBody>
+      </p:sp>
+      <p:sp>
+        <p:nvSpPr>
+          <p:cNvPr id="32" name="PROGRESS_FILL">
+            <a:extLst>
+              <a:ext uri="{FF2B5EF4-FFF2-40B4-BE49-F238E27FC236}">
+                <a16:creationId xmlns:a16="http://schemas.microsoft.com/office/drawing/2014/main" id="{463A790D-2C64-0A57-FB91-B0B4DC9B2692}"/>
+              </a:ext>
+            </a:extLst>
+          </p:cNvPr>
+          <p:cNvSpPr/>
+          <p:nvPr/>
+        </p:nvSpPr>
+        <p:spPr>
+          <a:xfrm>
+            <a:off x="553931" y="6507311"/>
+            <a:ext cx="1479807" cy="231006"/>
+          </a:xfrm>
+          <a:prstGeom prst="roundRect">
+            <a:avLst/>
+          </a:prstGeom>
+          <a:solidFill>
+            <a:srgbClr val="0D6EFD"/>
+          </a:solidFill>
+        </p:spPr>
+        <p:style>
+          <a:lnRef idx="1">
+            <a:schemeClr val="accent1"/>
+          </a:lnRef>
+          <a:fillRef idx="3">
+            <a:schemeClr val="accent1"/>
+          </a:fillRef>
+          <a:effectRef idx="2">
+            <a:schemeClr val="accent1"/>
+          </a:effectRef>
+          <a:fontRef idx="minor">
+            <a:schemeClr val="lt1"/>
+          </a:fontRef>
+        </p:style>
+        <p:txBody>
+          <a:bodyPr rtlCol="0" anchor="ctr"/>
+          <a:lstStyle/>
+          <a:p>
+            <a:pPr algn="ctr"/>
+            <a:endParaRPr lang="en-IN" dirty="0"/>
           </a:p>
         </p:txBody>
       </p:sp>
@@ -4592,71 +4780,6 @@
       </p:sp>
       <p:sp>
         <p:nvSpPr>
-          <p:cNvPr id="13" name="TextBox 12">
-            <a:extLst>
-              <a:ext uri="{FF2B5EF4-FFF2-40B4-BE49-F238E27FC236}">
-                <a16:creationId xmlns:a16="http://schemas.microsoft.com/office/drawing/2014/main" id="{0CF040D1-7AEE-F23C-8FFD-4CF774A52A05}"/>
-              </a:ext>
-            </a:extLst>
-          </p:cNvPr>
-          <p:cNvSpPr txBox="1"/>
-          <p:nvPr/>
-        </p:nvSpPr>
-        <p:spPr>
-          <a:xfrm>
-            <a:off x="226314" y="6356494"/>
-            <a:ext cx="1994105" cy="230832"/>
-          </a:xfrm>
-          <a:prstGeom prst="rect">
-            <a:avLst/>
-          </a:prstGeom>
-          <a:noFill/>
-        </p:spPr>
-        <p:txBody>
-          <a:bodyPr wrap="square" lIns="0" tIns="0" rIns="0" bIns="0" anchor="ctr">
-            <a:spAutoFit/>
-          </a:bodyPr>
-          <a:lstStyle/>
-          <a:p>
-            <a:pPr algn="ctr"/>
-            <a:r>
-              <a:rPr lang="en-GB" sz="1500" b="0" i="0" u="none" dirty="0">
-                <a:solidFill>
-                  <a:srgbClr val="64748B"/>
-                </a:solidFill>
-                <a:latin typeface="Poppins SemiBold"/>
-              </a:rPr>
-              <a:t>{{</a:t>
-            </a:r>
-            <a:r>
-              <a:rPr lang="en-GB" sz="1500" dirty="0">
-                <a:solidFill>
-                  <a:srgbClr val="64748B"/>
-                </a:solidFill>
-                <a:latin typeface="Poppins SemiBold"/>
-              </a:rPr>
-              <a:t>WORD_NUMBER</a:t>
-            </a:r>
-            <a:r>
-              <a:rPr lang="en-GB" sz="1500" b="0" i="0" u="none" dirty="0">
-                <a:solidFill>
-                  <a:srgbClr val="64748B"/>
-                </a:solidFill>
-                <a:latin typeface="Poppins SemiBold"/>
-              </a:rPr>
-              <a:t>}}</a:t>
-            </a:r>
-            <a:endParaRPr sz="1500" b="0" i="0" u="none" dirty="0">
-              <a:solidFill>
-                <a:srgbClr val="2563EB"/>
-              </a:solidFill>
-              <a:latin typeface="Poppins SemiBold"/>
-            </a:endParaRPr>
-          </a:p>
-        </p:txBody>
-      </p:sp>
-      <p:sp>
-        <p:nvSpPr>
           <p:cNvPr id="19" name="TextBox 18">
             <a:extLst>
               <a:ext uri="{FF2B5EF4-FFF2-40B4-BE49-F238E27FC236}">
@@ -4816,8 +4939,8 @@
         </p:blipFill>
         <p:spPr>
           <a:xfrm>
-            <a:off x="0" y="7061"/>
-            <a:ext cx="4719484" cy="3550377"/>
+            <a:off x="0" y="1"/>
+            <a:ext cx="4719484" cy="3557438"/>
           </a:xfrm>
           <a:prstGeom prst="rect">
             <a:avLst/>
@@ -5149,6 +5272,165 @@
               </a:solidFill>
               <a:latin typeface="Noto Sans SemiBold"/>
             </a:endParaRPr>
+          </a:p>
+        </p:txBody>
+      </p:sp>
+      <p:sp>
+        <p:nvSpPr>
+          <p:cNvPr id="7" name="TextBox 6">
+            <a:extLst>
+              <a:ext uri="{FF2B5EF4-FFF2-40B4-BE49-F238E27FC236}">
+                <a16:creationId xmlns:a16="http://schemas.microsoft.com/office/drawing/2014/main" id="{5335F20A-395F-DD90-A162-EAD3A8DF2F04}"/>
+              </a:ext>
+            </a:extLst>
+          </p:cNvPr>
+          <p:cNvSpPr txBox="1"/>
+          <p:nvPr/>
+        </p:nvSpPr>
+        <p:spPr>
+          <a:xfrm>
+            <a:off x="296784" y="6156796"/>
+            <a:ext cx="1994105" cy="230832"/>
+          </a:xfrm>
+          <a:prstGeom prst="rect">
+            <a:avLst/>
+          </a:prstGeom>
+          <a:noFill/>
+        </p:spPr>
+        <p:txBody>
+          <a:bodyPr wrap="square" lIns="0" tIns="0" rIns="0" bIns="0" anchor="ctr">
+            <a:spAutoFit/>
+          </a:bodyPr>
+          <a:lstStyle/>
+          <a:p>
+            <a:pPr algn="ctr"/>
+            <a:r>
+              <a:rPr lang="en-GB" sz="1500" b="0" i="0" u="none" dirty="0">
+                <a:solidFill>
+                  <a:srgbClr val="64748B"/>
+                </a:solidFill>
+                <a:latin typeface="Poppins SemiBold"/>
+              </a:rPr>
+              <a:t>{{</a:t>
+            </a:r>
+            <a:r>
+              <a:rPr lang="en-GB" sz="1500" dirty="0">
+                <a:solidFill>
+                  <a:srgbClr val="64748B"/>
+                </a:solidFill>
+                <a:latin typeface="Poppins SemiBold"/>
+              </a:rPr>
+              <a:t>WORD_NUMBER</a:t>
+            </a:r>
+            <a:r>
+              <a:rPr lang="en-GB" sz="1500" b="0" i="0" u="none" dirty="0">
+                <a:solidFill>
+                  <a:srgbClr val="64748B"/>
+                </a:solidFill>
+                <a:latin typeface="Poppins SemiBold"/>
+              </a:rPr>
+              <a:t>}}</a:t>
+            </a:r>
+            <a:endParaRPr sz="1500" b="0" i="0" u="none" dirty="0">
+              <a:solidFill>
+                <a:srgbClr val="2563EB"/>
+              </a:solidFill>
+              <a:latin typeface="Poppins SemiBold"/>
+            </a:endParaRPr>
+          </a:p>
+        </p:txBody>
+      </p:sp>
+      <p:sp>
+        <p:nvSpPr>
+          <p:cNvPr id="14" name="PROGRESS_TRACK">
+            <a:extLst>
+              <a:ext uri="{FF2B5EF4-FFF2-40B4-BE49-F238E27FC236}">
+                <a16:creationId xmlns:a16="http://schemas.microsoft.com/office/drawing/2014/main" id="{9AF7C590-F769-69F9-5040-AE90C7A8A7A8}"/>
+              </a:ext>
+            </a:extLst>
+          </p:cNvPr>
+          <p:cNvSpPr/>
+          <p:nvPr/>
+        </p:nvSpPr>
+        <p:spPr>
+          <a:xfrm>
+            <a:off x="553932" y="6507311"/>
+            <a:ext cx="1479807" cy="231006"/>
+          </a:xfrm>
+          <a:prstGeom prst="roundRect">
+            <a:avLst/>
+          </a:prstGeom>
+          <a:solidFill>
+            <a:srgbClr val="E0E0E0"/>
+          </a:solidFill>
+        </p:spPr>
+        <p:style>
+          <a:lnRef idx="1">
+            <a:schemeClr val="accent1"/>
+          </a:lnRef>
+          <a:fillRef idx="3">
+            <a:schemeClr val="accent1"/>
+          </a:fillRef>
+          <a:effectRef idx="2">
+            <a:schemeClr val="accent1"/>
+          </a:effectRef>
+          <a:fontRef idx="minor">
+            <a:schemeClr val="lt1"/>
+          </a:fontRef>
+        </p:style>
+        <p:txBody>
+          <a:bodyPr rtlCol="0" anchor="ctr"/>
+          <a:lstStyle/>
+          <a:p>
+            <a:pPr algn="ctr"/>
+            <a:endParaRPr lang="en-IN" dirty="0"/>
+          </a:p>
+        </p:txBody>
+      </p:sp>
+      <p:sp>
+        <p:nvSpPr>
+          <p:cNvPr id="20" name="PROGRESS_FILL">
+            <a:extLst>
+              <a:ext uri="{FF2B5EF4-FFF2-40B4-BE49-F238E27FC236}">
+                <a16:creationId xmlns:a16="http://schemas.microsoft.com/office/drawing/2014/main" id="{77525C4D-695F-A718-B34A-0053E8C533E3}"/>
+              </a:ext>
+            </a:extLst>
+          </p:cNvPr>
+          <p:cNvSpPr/>
+          <p:nvPr/>
+        </p:nvSpPr>
+        <p:spPr>
+          <a:xfrm>
+            <a:off x="553931" y="6507311"/>
+            <a:ext cx="1479807" cy="231006"/>
+          </a:xfrm>
+          <a:prstGeom prst="roundRect">
+            <a:avLst/>
+          </a:prstGeom>
+          <a:solidFill>
+            <a:srgbClr val="0D6EFD"/>
+          </a:solidFill>
+        </p:spPr>
+        <p:style>
+          <a:lnRef idx="1">
+            <a:schemeClr val="accent1"/>
+          </a:lnRef>
+          <a:fillRef idx="3">
+            <a:schemeClr val="accent1"/>
+          </a:fillRef>
+          <a:effectRef idx="2">
+            <a:schemeClr val="accent1"/>
+          </a:effectRef>
+          <a:fontRef idx="minor">
+            <a:schemeClr val="lt1"/>
+          </a:fontRef>
+        </p:style>
+        <p:txBody>
+          <a:bodyPr rtlCol="0" anchor="ctr"/>
+          <a:lstStyle/>
+          <a:p>
+            <a:pPr algn="ctr"/>
+            <a:endParaRPr lang="en-IN" dirty="0"/>
           </a:p>
         </p:txBody>
       </p:sp>
@@ -5382,71 +5664,6 @@
       </p:sp>
       <p:sp>
         <p:nvSpPr>
-          <p:cNvPr id="14" name="TextBox 13">
-            <a:extLst>
-              <a:ext uri="{FF2B5EF4-FFF2-40B4-BE49-F238E27FC236}">
-                <a16:creationId xmlns:a16="http://schemas.microsoft.com/office/drawing/2014/main" id="{D18E03C0-DDC1-2068-80EC-D8AB75DB105D}"/>
-              </a:ext>
-            </a:extLst>
-          </p:cNvPr>
-          <p:cNvSpPr txBox="1"/>
-          <p:nvPr/>
-        </p:nvSpPr>
-        <p:spPr>
-          <a:xfrm>
-            <a:off x="226314" y="6356494"/>
-            <a:ext cx="1994105" cy="230832"/>
-          </a:xfrm>
-          <a:prstGeom prst="rect">
-            <a:avLst/>
-          </a:prstGeom>
-          <a:noFill/>
-        </p:spPr>
-        <p:txBody>
-          <a:bodyPr wrap="square" lIns="0" tIns="0" rIns="0" bIns="0" anchor="ctr">
-            <a:spAutoFit/>
-          </a:bodyPr>
-          <a:lstStyle/>
-          <a:p>
-            <a:pPr algn="ctr"/>
-            <a:r>
-              <a:rPr lang="en-GB" sz="1500" b="0" i="0" u="none" dirty="0">
-                <a:solidFill>
-                  <a:srgbClr val="64748B"/>
-                </a:solidFill>
-                <a:latin typeface="Poppins SemiBold"/>
-              </a:rPr>
-              <a:t>{{</a:t>
-            </a:r>
-            <a:r>
-              <a:rPr lang="en-GB" sz="1500" dirty="0">
-                <a:solidFill>
-                  <a:srgbClr val="64748B"/>
-                </a:solidFill>
-                <a:latin typeface="Poppins SemiBold"/>
-              </a:rPr>
-              <a:t>WORD_NUMBER</a:t>
-            </a:r>
-            <a:r>
-              <a:rPr lang="en-GB" sz="1500" b="0" i="0" u="none" dirty="0">
-                <a:solidFill>
-                  <a:srgbClr val="64748B"/>
-                </a:solidFill>
-                <a:latin typeface="Poppins SemiBold"/>
-              </a:rPr>
-              <a:t>}}</a:t>
-            </a:r>
-            <a:endParaRPr sz="1500" b="0" i="0" u="none" dirty="0">
-              <a:solidFill>
-                <a:srgbClr val="2563EB"/>
-              </a:solidFill>
-              <a:latin typeface="Poppins SemiBold"/>
-            </a:endParaRPr>
-          </a:p>
-        </p:txBody>
-      </p:sp>
-      <p:sp>
-        <p:nvSpPr>
           <p:cNvPr id="20" name="TextBox 19">
             <a:extLst>
               <a:ext uri="{FF2B5EF4-FFF2-40B4-BE49-F238E27FC236}">
@@ -5606,8 +5823,8 @@
         </p:blipFill>
         <p:spPr>
           <a:xfrm>
-            <a:off x="0" y="7061"/>
-            <a:ext cx="4719484" cy="3550377"/>
+            <a:off x="0" y="1"/>
+            <a:ext cx="4719484" cy="3557438"/>
           </a:xfrm>
           <a:prstGeom prst="rect">
             <a:avLst/>
@@ -6003,6 +6220,165 @@
               </a:solidFill>
               <a:latin typeface="Noto Sans SemiBold"/>
             </a:endParaRPr>
+          </a:p>
+        </p:txBody>
+      </p:sp>
+      <p:sp>
+        <p:nvSpPr>
+          <p:cNvPr id="7" name="TextBox 6">
+            <a:extLst>
+              <a:ext uri="{FF2B5EF4-FFF2-40B4-BE49-F238E27FC236}">
+                <a16:creationId xmlns:a16="http://schemas.microsoft.com/office/drawing/2014/main" id="{15C75A85-7ACD-EC6C-BD01-74C02766CB35}"/>
+              </a:ext>
+            </a:extLst>
+          </p:cNvPr>
+          <p:cNvSpPr txBox="1"/>
+          <p:nvPr/>
+        </p:nvSpPr>
+        <p:spPr>
+          <a:xfrm>
+            <a:off x="296784" y="6156796"/>
+            <a:ext cx="1994105" cy="230832"/>
+          </a:xfrm>
+          <a:prstGeom prst="rect">
+            <a:avLst/>
+          </a:prstGeom>
+          <a:noFill/>
+        </p:spPr>
+        <p:txBody>
+          <a:bodyPr wrap="square" lIns="0" tIns="0" rIns="0" bIns="0" anchor="ctr">
+            <a:spAutoFit/>
+          </a:bodyPr>
+          <a:lstStyle/>
+          <a:p>
+            <a:pPr algn="ctr"/>
+            <a:r>
+              <a:rPr lang="en-GB" sz="1500" b="0" i="0" u="none" dirty="0">
+                <a:solidFill>
+                  <a:srgbClr val="64748B"/>
+                </a:solidFill>
+                <a:latin typeface="Poppins SemiBold"/>
+              </a:rPr>
+              <a:t>{{</a:t>
+            </a:r>
+            <a:r>
+              <a:rPr lang="en-GB" sz="1500" dirty="0">
+                <a:solidFill>
+                  <a:srgbClr val="64748B"/>
+                </a:solidFill>
+                <a:latin typeface="Poppins SemiBold"/>
+              </a:rPr>
+              <a:t>WORD_NUMBER</a:t>
+            </a:r>
+            <a:r>
+              <a:rPr lang="en-GB" sz="1500" b="0" i="0" u="none" dirty="0">
+                <a:solidFill>
+                  <a:srgbClr val="64748B"/>
+                </a:solidFill>
+                <a:latin typeface="Poppins SemiBold"/>
+              </a:rPr>
+              <a:t>}}</a:t>
+            </a:r>
+            <a:endParaRPr sz="1500" b="0" i="0" u="none" dirty="0">
+              <a:solidFill>
+                <a:srgbClr val="2563EB"/>
+              </a:solidFill>
+              <a:latin typeface="Poppins SemiBold"/>
+            </a:endParaRPr>
+          </a:p>
+        </p:txBody>
+      </p:sp>
+      <p:sp>
+        <p:nvSpPr>
+          <p:cNvPr id="16" name="PROGRESS_TRACK">
+            <a:extLst>
+              <a:ext uri="{FF2B5EF4-FFF2-40B4-BE49-F238E27FC236}">
+                <a16:creationId xmlns:a16="http://schemas.microsoft.com/office/drawing/2014/main" id="{190DD530-3681-6651-ABD7-ED25759DEBCF}"/>
+              </a:ext>
+            </a:extLst>
+          </p:cNvPr>
+          <p:cNvSpPr/>
+          <p:nvPr/>
+        </p:nvSpPr>
+        <p:spPr>
+          <a:xfrm>
+            <a:off x="553932" y="6507311"/>
+            <a:ext cx="1479807" cy="231006"/>
+          </a:xfrm>
+          <a:prstGeom prst="roundRect">
+            <a:avLst/>
+          </a:prstGeom>
+          <a:solidFill>
+            <a:srgbClr val="E0E0E0"/>
+          </a:solidFill>
+        </p:spPr>
+        <p:style>
+          <a:lnRef idx="1">
+            <a:schemeClr val="accent1"/>
+          </a:lnRef>
+          <a:fillRef idx="3">
+            <a:schemeClr val="accent1"/>
+          </a:fillRef>
+          <a:effectRef idx="2">
+            <a:schemeClr val="accent1"/>
+          </a:effectRef>
+          <a:fontRef idx="minor">
+            <a:schemeClr val="lt1"/>
+          </a:fontRef>
+        </p:style>
+        <p:txBody>
+          <a:bodyPr rtlCol="0" anchor="ctr"/>
+          <a:lstStyle/>
+          <a:p>
+            <a:pPr algn="ctr"/>
+            <a:endParaRPr lang="en-IN" dirty="0"/>
+          </a:p>
+        </p:txBody>
+      </p:sp>
+      <p:sp>
+        <p:nvSpPr>
+          <p:cNvPr id="21" name="PROGRESS_FILL">
+            <a:extLst>
+              <a:ext uri="{FF2B5EF4-FFF2-40B4-BE49-F238E27FC236}">
+                <a16:creationId xmlns:a16="http://schemas.microsoft.com/office/drawing/2014/main" id="{4B71666D-6536-CA5E-E603-EA34D3B0D5F2}"/>
+              </a:ext>
+            </a:extLst>
+          </p:cNvPr>
+          <p:cNvSpPr/>
+          <p:nvPr/>
+        </p:nvSpPr>
+        <p:spPr>
+          <a:xfrm>
+            <a:off x="553931" y="6507311"/>
+            <a:ext cx="1479807" cy="231006"/>
+          </a:xfrm>
+          <a:prstGeom prst="roundRect">
+            <a:avLst/>
+          </a:prstGeom>
+          <a:solidFill>
+            <a:srgbClr val="0D6EFD"/>
+          </a:solidFill>
+        </p:spPr>
+        <p:style>
+          <a:lnRef idx="1">
+            <a:schemeClr val="accent1"/>
+          </a:lnRef>
+          <a:fillRef idx="3">
+            <a:schemeClr val="accent1"/>
+          </a:fillRef>
+          <a:effectRef idx="2">
+            <a:schemeClr val="accent1"/>
+          </a:effectRef>
+          <a:fontRef idx="minor">
+            <a:schemeClr val="lt1"/>
+          </a:fontRef>
+        </p:style>
+        <p:txBody>
+          <a:bodyPr rtlCol="0" anchor="ctr"/>
+          <a:lstStyle/>
+          <a:p>
+            <a:pPr algn="ctr"/>
+            <a:endParaRPr lang="en-IN" dirty="0"/>
           </a:p>
         </p:txBody>
       </p:sp>

</xml_diff>

<commit_message>
Add continuity-focused presentation animations
</commit_message>
<xml_diff>
--- a/templates/vocabulary_template_v3.pptx
+++ b/templates/vocabulary_template_v3.pptx
@@ -305,7 +305,7 @@
           <a:p>
             <a:fld id="{5BCAD085-E8A6-8845-BD4E-CB4CCA059FC4}" type="datetimeFigureOut">
               <a:rPr lang="en-US" smtClean="0"/>
-              <a:t>8/21/2026</a:t>
+              <a:t>8/22/2026</a:t>
             </a:fld>
             <a:endParaRPr lang="en-US"/>
           </a:p>
@@ -473,7 +473,7 @@
           <a:p>
             <a:fld id="{5BCAD085-E8A6-8845-BD4E-CB4CCA059FC4}" type="datetimeFigureOut">
               <a:rPr lang="en-US" smtClean="0"/>
-              <a:t>8/21/2026</a:t>
+              <a:t>8/22/2026</a:t>
             </a:fld>
             <a:endParaRPr lang="en-US"/>
           </a:p>
@@ -651,7 +651,7 @@
           <a:p>
             <a:fld id="{5BCAD085-E8A6-8845-BD4E-CB4CCA059FC4}" type="datetimeFigureOut">
               <a:rPr lang="en-US" smtClean="0"/>
-              <a:t>8/21/2026</a:t>
+              <a:t>8/22/2026</a:t>
             </a:fld>
             <a:endParaRPr lang="en-US"/>
           </a:p>
@@ -819,7 +819,7 @@
           <a:p>
             <a:fld id="{5BCAD085-E8A6-8845-BD4E-CB4CCA059FC4}" type="datetimeFigureOut">
               <a:rPr lang="en-US" smtClean="0"/>
-              <a:t>8/21/2026</a:t>
+              <a:t>8/22/2026</a:t>
             </a:fld>
             <a:endParaRPr lang="en-US"/>
           </a:p>
@@ -1064,7 +1064,7 @@
           <a:p>
             <a:fld id="{5BCAD085-E8A6-8845-BD4E-CB4CCA059FC4}" type="datetimeFigureOut">
               <a:rPr lang="en-US" smtClean="0"/>
-              <a:t>8/21/2026</a:t>
+              <a:t>8/22/2026</a:t>
             </a:fld>
             <a:endParaRPr lang="en-US"/>
           </a:p>
@@ -1349,7 +1349,7 @@
           <a:p>
             <a:fld id="{5BCAD085-E8A6-8845-BD4E-CB4CCA059FC4}" type="datetimeFigureOut">
               <a:rPr lang="en-US" smtClean="0"/>
-              <a:t>8/21/2026</a:t>
+              <a:t>8/22/2026</a:t>
             </a:fld>
             <a:endParaRPr lang="en-US"/>
           </a:p>
@@ -1768,7 +1768,7 @@
           <a:p>
             <a:fld id="{5BCAD085-E8A6-8845-BD4E-CB4CCA059FC4}" type="datetimeFigureOut">
               <a:rPr lang="en-US" smtClean="0"/>
-              <a:t>8/21/2026</a:t>
+              <a:t>8/22/2026</a:t>
             </a:fld>
             <a:endParaRPr lang="en-US"/>
           </a:p>
@@ -1885,7 +1885,7 @@
           <a:p>
             <a:fld id="{5BCAD085-E8A6-8845-BD4E-CB4CCA059FC4}" type="datetimeFigureOut">
               <a:rPr lang="en-US" smtClean="0"/>
-              <a:t>8/21/2026</a:t>
+              <a:t>8/22/2026</a:t>
             </a:fld>
             <a:endParaRPr lang="en-US"/>
           </a:p>
@@ -1980,7 +1980,7 @@
           <a:p>
             <a:fld id="{5BCAD085-E8A6-8845-BD4E-CB4CCA059FC4}" type="datetimeFigureOut">
               <a:rPr lang="en-US" smtClean="0"/>
-              <a:t>8/21/2026</a:t>
+              <a:t>8/22/2026</a:t>
             </a:fld>
             <a:endParaRPr lang="en-US"/>
           </a:p>
@@ -2255,7 +2255,7 @@
           <a:p>
             <a:fld id="{5BCAD085-E8A6-8845-BD4E-CB4CCA059FC4}" type="datetimeFigureOut">
               <a:rPr lang="en-US" smtClean="0"/>
-              <a:t>8/21/2026</a:t>
+              <a:t>8/22/2026</a:t>
             </a:fld>
             <a:endParaRPr lang="en-US"/>
           </a:p>
@@ -2507,7 +2507,7 @@
           <a:p>
             <a:fld id="{5BCAD085-E8A6-8845-BD4E-CB4CCA059FC4}" type="datetimeFigureOut">
               <a:rPr lang="en-US" smtClean="0"/>
-              <a:t>8/21/2026</a:t>
+              <a:t>8/22/2026</a:t>
             </a:fld>
             <a:endParaRPr lang="en-US"/>
           </a:p>
@@ -2718,7 +2718,7 @@
           <a:p>
             <a:fld id="{5BCAD085-E8A6-8845-BD4E-CB4CCA059FC4}" type="datetimeFigureOut">
               <a:rPr lang="en-US" smtClean="0"/>
-              <a:t>8/21/2026</a:t>
+              <a:t>8/22/2026</a:t>
             </a:fld>
             <a:endParaRPr lang="en-US"/>
           </a:p>
@@ -3914,7 +3914,7 @@
       </p:pic>
       <p:sp>
         <p:nvSpPr>
-          <p:cNvPr id="15" name="TextBox 14">
+          <p:cNvPr id="15" name="PAST_SENTENCE">
             <a:extLst>
               <a:ext uri="{FF2B5EF4-FFF2-40B4-BE49-F238E27FC236}">
                 <a16:creationId xmlns:a16="http://schemas.microsoft.com/office/drawing/2014/main" id="{16EB2755-2C05-216C-E7F7-E2AE9F2E1A93}"/>
@@ -4716,7 +4716,7 @@
       </p:pic>
       <p:sp>
         <p:nvSpPr>
-          <p:cNvPr id="16" name="TextBox 15">
+          <p:cNvPr id="16" name="PRESENT_SENTENCE">
             <a:extLst>
               <a:ext uri="{FF2B5EF4-FFF2-40B4-BE49-F238E27FC236}">
                 <a16:creationId xmlns:a16="http://schemas.microsoft.com/office/drawing/2014/main" id="{867BCAC7-9746-3084-D20B-C02A99CD59B2}"/>
@@ -5582,7 +5582,7 @@
       </p:pic>
       <p:sp>
         <p:nvSpPr>
-          <p:cNvPr id="10" name="TextBox 9">
+          <p:cNvPr id="10" name="FUTURE_SENTENCE">
             <a:extLst>
               <a:ext uri="{FF2B5EF4-FFF2-40B4-BE49-F238E27FC236}">
                 <a16:creationId xmlns:a16="http://schemas.microsoft.com/office/drawing/2014/main" id="{A7719EB7-F939-9669-5498-08964765C4AB}"/>

</xml_diff>

<commit_message>
Stabilize audio and presentation media timing
</commit_message>
<xml_diff>
--- a/templates/vocabulary_template_v3.pptx
+++ b/templates/vocabulary_template_v3.pptx
@@ -305,7 +305,7 @@
           <a:p>
             <a:fld id="{5BCAD085-E8A6-8845-BD4E-CB4CCA059FC4}" type="datetimeFigureOut">
               <a:rPr lang="en-US" smtClean="0"/>
-              <a:t>8/22/2026</a:t>
+              <a:t>8/24/2026</a:t>
             </a:fld>
             <a:endParaRPr lang="en-US"/>
           </a:p>
@@ -473,7 +473,7 @@
           <a:p>
             <a:fld id="{5BCAD085-E8A6-8845-BD4E-CB4CCA059FC4}" type="datetimeFigureOut">
               <a:rPr lang="en-US" smtClean="0"/>
-              <a:t>8/22/2026</a:t>
+              <a:t>8/24/2026</a:t>
             </a:fld>
             <a:endParaRPr lang="en-US"/>
           </a:p>
@@ -651,7 +651,7 @@
           <a:p>
             <a:fld id="{5BCAD085-E8A6-8845-BD4E-CB4CCA059FC4}" type="datetimeFigureOut">
               <a:rPr lang="en-US" smtClean="0"/>
-              <a:t>8/22/2026</a:t>
+              <a:t>8/24/2026</a:t>
             </a:fld>
             <a:endParaRPr lang="en-US"/>
           </a:p>
@@ -819,7 +819,7 @@
           <a:p>
             <a:fld id="{5BCAD085-E8A6-8845-BD4E-CB4CCA059FC4}" type="datetimeFigureOut">
               <a:rPr lang="en-US" smtClean="0"/>
-              <a:t>8/22/2026</a:t>
+              <a:t>8/24/2026</a:t>
             </a:fld>
             <a:endParaRPr lang="en-US"/>
           </a:p>
@@ -1064,7 +1064,7 @@
           <a:p>
             <a:fld id="{5BCAD085-E8A6-8845-BD4E-CB4CCA059FC4}" type="datetimeFigureOut">
               <a:rPr lang="en-US" smtClean="0"/>
-              <a:t>8/22/2026</a:t>
+              <a:t>8/24/2026</a:t>
             </a:fld>
             <a:endParaRPr lang="en-US"/>
           </a:p>
@@ -1349,7 +1349,7 @@
           <a:p>
             <a:fld id="{5BCAD085-E8A6-8845-BD4E-CB4CCA059FC4}" type="datetimeFigureOut">
               <a:rPr lang="en-US" smtClean="0"/>
-              <a:t>8/22/2026</a:t>
+              <a:t>8/24/2026</a:t>
             </a:fld>
             <a:endParaRPr lang="en-US"/>
           </a:p>
@@ -1768,7 +1768,7 @@
           <a:p>
             <a:fld id="{5BCAD085-E8A6-8845-BD4E-CB4CCA059FC4}" type="datetimeFigureOut">
               <a:rPr lang="en-US" smtClean="0"/>
-              <a:t>8/22/2026</a:t>
+              <a:t>8/24/2026</a:t>
             </a:fld>
             <a:endParaRPr lang="en-US"/>
           </a:p>
@@ -1885,7 +1885,7 @@
           <a:p>
             <a:fld id="{5BCAD085-E8A6-8845-BD4E-CB4CCA059FC4}" type="datetimeFigureOut">
               <a:rPr lang="en-US" smtClean="0"/>
-              <a:t>8/22/2026</a:t>
+              <a:t>8/24/2026</a:t>
             </a:fld>
             <a:endParaRPr lang="en-US"/>
           </a:p>
@@ -1980,7 +1980,7 @@
           <a:p>
             <a:fld id="{5BCAD085-E8A6-8845-BD4E-CB4CCA059FC4}" type="datetimeFigureOut">
               <a:rPr lang="en-US" smtClean="0"/>
-              <a:t>8/22/2026</a:t>
+              <a:t>8/24/2026</a:t>
             </a:fld>
             <a:endParaRPr lang="en-US"/>
           </a:p>
@@ -2255,7 +2255,7 @@
           <a:p>
             <a:fld id="{5BCAD085-E8A6-8845-BD4E-CB4CCA059FC4}" type="datetimeFigureOut">
               <a:rPr lang="en-US" smtClean="0"/>
-              <a:t>8/22/2026</a:t>
+              <a:t>8/24/2026</a:t>
             </a:fld>
             <a:endParaRPr lang="en-US"/>
           </a:p>
@@ -2507,7 +2507,7 @@
           <a:p>
             <a:fld id="{5BCAD085-E8A6-8845-BD4E-CB4CCA059FC4}" type="datetimeFigureOut">
               <a:rPr lang="en-US" smtClean="0"/>
-              <a:t>8/22/2026</a:t>
+              <a:t>8/24/2026</a:t>
             </a:fld>
             <a:endParaRPr lang="en-US"/>
           </a:p>
@@ -2718,7 +2718,7 @@
           <a:p>
             <a:fld id="{5BCAD085-E8A6-8845-BD4E-CB4CCA059FC4}" type="datetimeFigureOut">
               <a:rPr lang="en-US" smtClean="0"/>
-              <a:t>8/22/2026</a:t>
+              <a:t>8/24/2026</a:t>
             </a:fld>
             <a:endParaRPr lang="en-US"/>
           </a:p>
@@ -3240,8 +3240,8 @@
         </p:nvSpPr>
         <p:spPr>
           <a:xfrm>
-            <a:off x="5515897" y="213702"/>
-            <a:ext cx="6517097" cy="1171475"/>
+            <a:off x="4572001" y="213702"/>
+            <a:ext cx="7460994" cy="1171475"/>
           </a:xfrm>
           <a:prstGeom prst="rect">
             <a:avLst/>
@@ -3327,7 +3327,7 @@
         <p:spPr>
           <a:xfrm>
             <a:off x="4889704" y="2526335"/>
-            <a:ext cx="3806620" cy="1107996"/>
+            <a:ext cx="3806620" cy="923330"/>
           </a:xfrm>
           <a:prstGeom prst="rect">
             <a:avLst/>
@@ -3342,7 +3342,7 @@
           <a:p>
             <a:pPr algn="ctr"/>
             <a:r>
-              <a:rPr lang="en-GB" sz="2400" b="0" i="0" u="none" dirty="0">
+              <a:rPr lang="en-GB" sz="2000" b="0" i="0" u="none" dirty="0">
                 <a:solidFill>
                   <a:srgbClr val="475569"/>
                 </a:solidFill>
@@ -3351,7 +3351,7 @@
               <a:t>{{</a:t>
             </a:r>
             <a:r>
-              <a:rPr lang="en-GB" sz="2400" dirty="0">
+              <a:rPr lang="en-GB" sz="2000" dirty="0">
                 <a:solidFill>
                   <a:srgbClr val="475569"/>
                 </a:solidFill>
@@ -3360,7 +3360,7 @@
               <a:t>HINDI</a:t>
             </a:r>
             <a:r>
-              <a:rPr lang="en-GB" sz="2400" b="0" i="0" u="none" dirty="0">
+              <a:rPr lang="en-GB" sz="2000" b="0" i="0" u="none" dirty="0">
                 <a:solidFill>
                   <a:srgbClr val="475569"/>
                 </a:solidFill>
@@ -3369,7 +3369,7 @@
               <a:t>}}</a:t>
             </a:r>
             <a:r>
-              <a:rPr sz="2400" b="0" i="0" u="none" dirty="0">
+              <a:rPr sz="2000" b="0" i="0" u="none" dirty="0">
                 <a:solidFill>
                   <a:srgbClr val="475569"/>
                 </a:solidFill>
@@ -3378,12 +3378,12 @@
               <a:t>,</a:t>
             </a:r>
             <a:r>
-              <a:rPr dirty="0"/>
+              <a:rPr sz="2000" dirty="0"/>
               <a:t>
 </a:t>
             </a:r>
             <a:r>
-              <a:rPr sz="2400" b="0" i="0" u="none" dirty="0">
+              <a:rPr sz="2000" b="0" i="0" u="none" dirty="0">
                 <a:solidFill>
                   <a:srgbClr val="475569"/>
                 </a:solidFill>
@@ -3392,7 +3392,7 @@
               <a:t> </a:t>
             </a:r>
             <a:r>
-              <a:rPr lang="en-GB" sz="2400" b="0" i="0" u="none" dirty="0">
+              <a:rPr lang="en-GB" sz="2000" b="0" i="0" u="none" dirty="0">
                 <a:solidFill>
                   <a:srgbClr val="475569"/>
                 </a:solidFill>
@@ -3401,7 +3401,7 @@
               <a:t>{{</a:t>
             </a:r>
             <a:r>
-              <a:rPr lang="en-GB" sz="2400" dirty="0">
+              <a:rPr lang="en-GB" sz="2000" dirty="0">
                 <a:solidFill>
                   <a:srgbClr val="475569"/>
                 </a:solidFill>
@@ -3410,7 +3410,7 @@
               <a:t>MALAYALAM</a:t>
             </a:r>
             <a:r>
-              <a:rPr lang="en-GB" sz="2400" b="0" i="0" u="none" dirty="0">
+              <a:rPr lang="en-GB" sz="2000" b="0" i="0" u="none" dirty="0">
                 <a:solidFill>
                   <a:srgbClr val="475569"/>
                 </a:solidFill>
@@ -3419,7 +3419,7 @@
               <a:t>}}</a:t>
             </a:r>
             <a:r>
-              <a:rPr sz="2400" b="0" i="0" u="none" dirty="0">
+              <a:rPr sz="2000" b="0" i="0" u="none" dirty="0">
                 <a:solidFill>
                   <a:srgbClr val="475569"/>
                 </a:solidFill>
@@ -3428,12 +3428,12 @@
               <a:t>,</a:t>
             </a:r>
             <a:r>
-              <a:rPr dirty="0"/>
+              <a:rPr sz="2000" dirty="0"/>
               <a:t>
 </a:t>
             </a:r>
             <a:r>
-              <a:rPr sz="2400" b="0" i="0" u="none" dirty="0">
+              <a:rPr sz="2000" b="0" i="0" u="none" dirty="0">
                 <a:solidFill>
                   <a:srgbClr val="475569"/>
                 </a:solidFill>
@@ -3442,7 +3442,7 @@
               <a:t> </a:t>
             </a:r>
             <a:r>
-              <a:rPr lang="en-GB" sz="2400" b="0" i="0" u="none" dirty="0">
+              <a:rPr lang="en-GB" sz="2000" b="0" i="0" u="none" dirty="0">
                 <a:solidFill>
                   <a:srgbClr val="475569"/>
                 </a:solidFill>
@@ -3451,7 +3451,7 @@
               <a:t>{{</a:t>
             </a:r>
             <a:r>
-              <a:rPr lang="en-GB" sz="2400" dirty="0">
+              <a:rPr lang="en-GB" sz="2000" dirty="0">
                 <a:solidFill>
                   <a:srgbClr val="475569"/>
                 </a:solidFill>
@@ -3460,7 +3460,7 @@
               <a:t>TAMIL</a:t>
             </a:r>
             <a:r>
-              <a:rPr lang="en-GB" sz="2400" b="0" i="0" u="none" dirty="0">
+              <a:rPr lang="en-GB" sz="2000" b="0" i="0" u="none" dirty="0">
                 <a:solidFill>
                   <a:srgbClr val="475569"/>
                 </a:solidFill>
@@ -3468,7 +3468,7 @@
               </a:rPr>
               <a:t>}}</a:t>
             </a:r>
-            <a:endParaRPr sz="2400" b="0" i="0" u="none" dirty="0">
+            <a:endParaRPr sz="2000" b="0" i="0" u="none" dirty="0">
               <a:solidFill>
                 <a:srgbClr val="475569"/>
               </a:solidFill>
@@ -4083,57 +4083,6 @@
       </p:pic>
       <p:sp>
         <p:nvSpPr>
-          <p:cNvPr id="10" name="TextBox 9">
-            <a:extLst>
-              <a:ext uri="{FF2B5EF4-FFF2-40B4-BE49-F238E27FC236}">
-                <a16:creationId xmlns:a16="http://schemas.microsoft.com/office/drawing/2014/main" id="{BA6C92D8-B625-9D83-E207-CF54C1744E87}"/>
-              </a:ext>
-            </a:extLst>
-          </p:cNvPr>
-          <p:cNvSpPr txBox="1"/>
-          <p:nvPr/>
-        </p:nvSpPr>
-        <p:spPr>
-          <a:xfrm>
-            <a:off x="5515897" y="213702"/>
-            <a:ext cx="6517097" cy="1171475"/>
-          </a:xfrm>
-          <a:prstGeom prst="rect">
-            <a:avLst/>
-          </a:prstGeom>
-          <a:noFill/>
-        </p:spPr>
-        <p:txBody>
-          <a:bodyPr wrap="square" lIns="0" tIns="0" rIns="0" bIns="0" anchor="t">
-            <a:spAutoFit/>
-          </a:bodyPr>
-          <a:lstStyle/>
-          <a:p>
-            <a:pPr algn="ctr">
-              <a:lnSpc>
-                <a:spcPts val="9075"/>
-              </a:lnSpc>
-            </a:pPr>
-            <a:r>
-              <a:rPr lang="en-GB" sz="7400" b="0" i="0" u="none" dirty="0">
-                <a:solidFill>
-                  <a:srgbClr val="0F172A"/>
-                </a:solidFill>
-                <a:latin typeface="Poppins ExtraBold"/>
-              </a:rPr>
-              <a:t>{{WORD}}</a:t>
-            </a:r>
-            <a:endParaRPr sz="7400" b="0" i="0" u="none" dirty="0">
-              <a:solidFill>
-                <a:srgbClr val="0F172A"/>
-              </a:solidFill>
-              <a:latin typeface="Poppins ExtraBold"/>
-            </a:endParaRPr>
-          </a:p>
-        </p:txBody>
-      </p:sp>
-      <p:sp>
-        <p:nvSpPr>
           <p:cNvPr id="20" name="TextBox 19">
             <a:extLst>
               <a:ext uri="{FF2B5EF4-FFF2-40B4-BE49-F238E27FC236}">
@@ -4259,7 +4208,7 @@
         <p:spPr>
           <a:xfrm>
             <a:off x="4889704" y="2526335"/>
-            <a:ext cx="3806620" cy="1107996"/>
+            <a:ext cx="3806620" cy="923330"/>
           </a:xfrm>
           <a:prstGeom prst="rect">
             <a:avLst/>
@@ -4274,7 +4223,7 @@
           <a:p>
             <a:pPr algn="ctr"/>
             <a:r>
-              <a:rPr lang="en-GB" sz="2400" b="0" i="0" u="none" dirty="0">
+              <a:rPr lang="en-GB" sz="2000" b="0" i="0" u="none" dirty="0">
                 <a:solidFill>
                   <a:srgbClr val="475569"/>
                 </a:solidFill>
@@ -4283,7 +4232,7 @@
               <a:t>{{</a:t>
             </a:r>
             <a:r>
-              <a:rPr lang="en-GB" sz="2400" dirty="0">
+              <a:rPr lang="en-GB" sz="2000" dirty="0">
                 <a:solidFill>
                   <a:srgbClr val="475569"/>
                 </a:solidFill>
@@ -4292,7 +4241,7 @@
               <a:t>HINDI</a:t>
             </a:r>
             <a:r>
-              <a:rPr lang="en-GB" sz="2400" b="0" i="0" u="none" dirty="0">
+              <a:rPr lang="en-GB" sz="2000" b="0" i="0" u="none" dirty="0">
                 <a:solidFill>
                   <a:srgbClr val="475569"/>
                 </a:solidFill>
@@ -4301,7 +4250,7 @@
               <a:t>}}</a:t>
             </a:r>
             <a:r>
-              <a:rPr sz="2400" b="0" i="0" u="none" dirty="0">
+              <a:rPr sz="2000" b="0" i="0" u="none" dirty="0">
                 <a:solidFill>
                   <a:srgbClr val="475569"/>
                 </a:solidFill>
@@ -4310,12 +4259,12 @@
               <a:t>,</a:t>
             </a:r>
             <a:r>
-              <a:rPr dirty="0"/>
+              <a:rPr sz="2000" dirty="0"/>
               <a:t>
 </a:t>
             </a:r>
             <a:r>
-              <a:rPr sz="2400" b="0" i="0" u="none" dirty="0">
+              <a:rPr sz="2000" b="0" i="0" u="none" dirty="0">
                 <a:solidFill>
                   <a:srgbClr val="475569"/>
                 </a:solidFill>
@@ -4324,7 +4273,7 @@
               <a:t> </a:t>
             </a:r>
             <a:r>
-              <a:rPr lang="en-GB" sz="2400" b="0" i="0" u="none" dirty="0">
+              <a:rPr lang="en-GB" sz="2000" b="0" i="0" u="none" dirty="0">
                 <a:solidFill>
                   <a:srgbClr val="475569"/>
                 </a:solidFill>
@@ -4333,7 +4282,7 @@
               <a:t>{{</a:t>
             </a:r>
             <a:r>
-              <a:rPr lang="en-GB" sz="2400" dirty="0">
+              <a:rPr lang="en-GB" sz="2000" dirty="0">
                 <a:solidFill>
                   <a:srgbClr val="475569"/>
                 </a:solidFill>
@@ -4342,7 +4291,7 @@
               <a:t>MALAYALAM</a:t>
             </a:r>
             <a:r>
-              <a:rPr lang="en-GB" sz="2400" b="0" i="0" u="none" dirty="0">
+              <a:rPr lang="en-GB" sz="2000" b="0" i="0" u="none" dirty="0">
                 <a:solidFill>
                   <a:srgbClr val="475569"/>
                 </a:solidFill>
@@ -4351,7 +4300,7 @@
               <a:t>}}</a:t>
             </a:r>
             <a:r>
-              <a:rPr sz="2400" b="0" i="0" u="none" dirty="0">
+              <a:rPr sz="2000" b="0" i="0" u="none" dirty="0">
                 <a:solidFill>
                   <a:srgbClr val="475569"/>
                 </a:solidFill>
@@ -4360,12 +4309,12 @@
               <a:t>,</a:t>
             </a:r>
             <a:r>
-              <a:rPr dirty="0"/>
+              <a:rPr sz="2000" dirty="0"/>
               <a:t>
 </a:t>
             </a:r>
             <a:r>
-              <a:rPr sz="2400" b="0" i="0" u="none" dirty="0">
+              <a:rPr sz="2000" b="0" i="0" u="none" dirty="0">
                 <a:solidFill>
                   <a:srgbClr val="475569"/>
                 </a:solidFill>
@@ -4374,7 +4323,7 @@
               <a:t> </a:t>
             </a:r>
             <a:r>
-              <a:rPr lang="en-GB" sz="2400" b="0" i="0" u="none" dirty="0">
+              <a:rPr lang="en-GB" sz="2000" b="0" i="0" u="none" dirty="0">
                 <a:solidFill>
                   <a:srgbClr val="475569"/>
                 </a:solidFill>
@@ -4383,7 +4332,7 @@
               <a:t>{{</a:t>
             </a:r>
             <a:r>
-              <a:rPr lang="en-GB" sz="2400" dirty="0">
+              <a:rPr lang="en-GB" sz="2000" dirty="0">
                 <a:solidFill>
                   <a:srgbClr val="475569"/>
                 </a:solidFill>
@@ -4392,7 +4341,7 @@
               <a:t>TAMIL</a:t>
             </a:r>
             <a:r>
-              <a:rPr lang="en-GB" sz="2400" b="0" i="0" u="none" dirty="0">
+              <a:rPr lang="en-GB" sz="2000" b="0" i="0" u="none" dirty="0">
                 <a:solidFill>
                   <a:srgbClr val="475569"/>
                 </a:solidFill>
@@ -4400,7 +4349,7 @@
               </a:rPr>
               <a:t>}}</a:t>
             </a:r>
-            <a:endParaRPr sz="2400" b="0" i="0" u="none" dirty="0">
+            <a:endParaRPr sz="2000" b="0" i="0" u="none" dirty="0">
               <a:solidFill>
                 <a:srgbClr val="475569"/>
               </a:solidFill>
@@ -4565,6 +4514,57 @@
           <a:p>
             <a:pPr algn="ctr"/>
             <a:endParaRPr lang="en-IN" dirty="0"/>
+          </a:p>
+        </p:txBody>
+      </p:sp>
+      <p:sp>
+        <p:nvSpPr>
+          <p:cNvPr id="4" name="TextBox 3">
+            <a:extLst>
+              <a:ext uri="{FF2B5EF4-FFF2-40B4-BE49-F238E27FC236}">
+                <a16:creationId xmlns:a16="http://schemas.microsoft.com/office/drawing/2014/main" id="{643872ED-18F2-C34B-B1D2-205CA03136BD}"/>
+              </a:ext>
+            </a:extLst>
+          </p:cNvPr>
+          <p:cNvSpPr txBox="1"/>
+          <p:nvPr/>
+        </p:nvSpPr>
+        <p:spPr>
+          <a:xfrm>
+            <a:off x="4572001" y="213702"/>
+            <a:ext cx="7460994" cy="1171475"/>
+          </a:xfrm>
+          <a:prstGeom prst="rect">
+            <a:avLst/>
+          </a:prstGeom>
+          <a:noFill/>
+        </p:spPr>
+        <p:txBody>
+          <a:bodyPr wrap="square" lIns="0" tIns="0" rIns="0" bIns="0" anchor="t">
+            <a:spAutoFit/>
+          </a:bodyPr>
+          <a:lstStyle/>
+          <a:p>
+            <a:pPr algn="ctr">
+              <a:lnSpc>
+                <a:spcPts val="9075"/>
+              </a:lnSpc>
+            </a:pPr>
+            <a:r>
+              <a:rPr lang="en-GB" sz="7400" b="0" i="0" u="none" dirty="0">
+                <a:solidFill>
+                  <a:srgbClr val="0F172A"/>
+                </a:solidFill>
+                <a:latin typeface="Poppins ExtraBold"/>
+              </a:rPr>
+              <a:t>{{WORD}}</a:t>
+            </a:r>
+            <a:endParaRPr sz="7400" b="0" i="0" u="none" dirty="0">
+              <a:solidFill>
+                <a:srgbClr val="0F172A"/>
+              </a:solidFill>
+              <a:latin typeface="Poppins ExtraBold"/>
+            </a:endParaRPr>
           </a:p>
         </p:txBody>
       </p:sp>
@@ -4949,57 +4949,6 @@
       </p:pic>
       <p:sp>
         <p:nvSpPr>
-          <p:cNvPr id="6" name="TextBox 5">
-            <a:extLst>
-              <a:ext uri="{FF2B5EF4-FFF2-40B4-BE49-F238E27FC236}">
-                <a16:creationId xmlns:a16="http://schemas.microsoft.com/office/drawing/2014/main" id="{E1D5E0B8-1969-5150-7E87-49689D59AFBF}"/>
-              </a:ext>
-            </a:extLst>
-          </p:cNvPr>
-          <p:cNvSpPr txBox="1"/>
-          <p:nvPr/>
-        </p:nvSpPr>
-        <p:spPr>
-          <a:xfrm>
-            <a:off x="5515897" y="213702"/>
-            <a:ext cx="6517097" cy="1171475"/>
-          </a:xfrm>
-          <a:prstGeom prst="rect">
-            <a:avLst/>
-          </a:prstGeom>
-          <a:noFill/>
-        </p:spPr>
-        <p:txBody>
-          <a:bodyPr wrap="square" lIns="0" tIns="0" rIns="0" bIns="0" anchor="t">
-            <a:spAutoFit/>
-          </a:bodyPr>
-          <a:lstStyle/>
-          <a:p>
-            <a:pPr algn="ctr">
-              <a:lnSpc>
-                <a:spcPts val="9075"/>
-              </a:lnSpc>
-            </a:pPr>
-            <a:r>
-              <a:rPr lang="en-GB" sz="7400" b="0" i="0" u="none" dirty="0">
-                <a:solidFill>
-                  <a:srgbClr val="0F172A"/>
-                </a:solidFill>
-                <a:latin typeface="Poppins ExtraBold"/>
-              </a:rPr>
-              <a:t>{{WORD}}</a:t>
-            </a:r>
-            <a:endParaRPr sz="7400" b="0" i="0" u="none" dirty="0">
-              <a:solidFill>
-                <a:srgbClr val="0F172A"/>
-              </a:solidFill>
-              <a:latin typeface="Poppins ExtraBold"/>
-            </a:endParaRPr>
-          </a:p>
-        </p:txBody>
-      </p:sp>
-      <p:sp>
-        <p:nvSpPr>
           <p:cNvPr id="12" name="TextBox 11">
             <a:extLst>
               <a:ext uri="{FF2B5EF4-FFF2-40B4-BE49-F238E27FC236}">
@@ -5125,7 +5074,7 @@
         <p:spPr>
           <a:xfrm>
             <a:off x="4889704" y="2526335"/>
-            <a:ext cx="3806620" cy="1107996"/>
+            <a:ext cx="3806620" cy="923330"/>
           </a:xfrm>
           <a:prstGeom prst="rect">
             <a:avLst/>
@@ -5140,7 +5089,7 @@
           <a:p>
             <a:pPr algn="ctr"/>
             <a:r>
-              <a:rPr lang="en-GB" sz="2400" b="0" i="0" u="none" dirty="0">
+              <a:rPr lang="en-GB" sz="2000" b="0" i="0" u="none" dirty="0">
                 <a:solidFill>
                   <a:srgbClr val="475569"/>
                 </a:solidFill>
@@ -5149,7 +5098,7 @@
               <a:t>{{</a:t>
             </a:r>
             <a:r>
-              <a:rPr lang="en-GB" sz="2400" dirty="0">
+              <a:rPr lang="en-GB" sz="2000" dirty="0">
                 <a:solidFill>
                   <a:srgbClr val="475569"/>
                 </a:solidFill>
@@ -5158,7 +5107,7 @@
               <a:t>HINDI</a:t>
             </a:r>
             <a:r>
-              <a:rPr lang="en-GB" sz="2400" b="0" i="0" u="none" dirty="0">
+              <a:rPr lang="en-GB" sz="2000" b="0" i="0" u="none" dirty="0">
                 <a:solidFill>
                   <a:srgbClr val="475569"/>
                 </a:solidFill>
@@ -5167,7 +5116,7 @@
               <a:t>}}</a:t>
             </a:r>
             <a:r>
-              <a:rPr sz="2400" b="0" i="0" u="none" dirty="0">
+              <a:rPr sz="2000" b="0" i="0" u="none" dirty="0">
                 <a:solidFill>
                   <a:srgbClr val="475569"/>
                 </a:solidFill>
@@ -5176,12 +5125,12 @@
               <a:t>,</a:t>
             </a:r>
             <a:r>
-              <a:rPr dirty="0"/>
+              <a:rPr sz="2000" dirty="0"/>
               <a:t>
 </a:t>
             </a:r>
             <a:r>
-              <a:rPr sz="2400" b="0" i="0" u="none" dirty="0">
+              <a:rPr sz="2000" b="0" i="0" u="none" dirty="0">
                 <a:solidFill>
                   <a:srgbClr val="475569"/>
                 </a:solidFill>
@@ -5190,7 +5139,7 @@
               <a:t> </a:t>
             </a:r>
             <a:r>
-              <a:rPr lang="en-GB" sz="2400" b="0" i="0" u="none" dirty="0">
+              <a:rPr lang="en-GB" sz="2000" b="0" i="0" u="none" dirty="0">
                 <a:solidFill>
                   <a:srgbClr val="475569"/>
                 </a:solidFill>
@@ -5199,7 +5148,7 @@
               <a:t>{{</a:t>
             </a:r>
             <a:r>
-              <a:rPr lang="en-GB" sz="2400" dirty="0">
+              <a:rPr lang="en-GB" sz="2000" dirty="0">
                 <a:solidFill>
                   <a:srgbClr val="475569"/>
                 </a:solidFill>
@@ -5208,7 +5157,7 @@
               <a:t>MALAYALAM</a:t>
             </a:r>
             <a:r>
-              <a:rPr lang="en-GB" sz="2400" b="0" i="0" u="none" dirty="0">
+              <a:rPr lang="en-GB" sz="2000" b="0" i="0" u="none" dirty="0">
                 <a:solidFill>
                   <a:srgbClr val="475569"/>
                 </a:solidFill>
@@ -5217,7 +5166,7 @@
               <a:t>}}</a:t>
             </a:r>
             <a:r>
-              <a:rPr sz="2400" b="0" i="0" u="none" dirty="0">
+              <a:rPr sz="2000" b="0" i="0" u="none" dirty="0">
                 <a:solidFill>
                   <a:srgbClr val="475569"/>
                 </a:solidFill>
@@ -5226,12 +5175,12 @@
               <a:t>,</a:t>
             </a:r>
             <a:r>
-              <a:rPr dirty="0"/>
+              <a:rPr sz="2000" dirty="0"/>
               <a:t>
 </a:t>
             </a:r>
             <a:r>
-              <a:rPr sz="2400" b="0" i="0" u="none" dirty="0">
+              <a:rPr sz="2000" b="0" i="0" u="none" dirty="0">
                 <a:solidFill>
                   <a:srgbClr val="475569"/>
                 </a:solidFill>
@@ -5240,7 +5189,7 @@
               <a:t> </a:t>
             </a:r>
             <a:r>
-              <a:rPr lang="en-GB" sz="2400" b="0" i="0" u="none" dirty="0">
+              <a:rPr lang="en-GB" sz="2000" b="0" i="0" u="none" dirty="0">
                 <a:solidFill>
                   <a:srgbClr val="475569"/>
                 </a:solidFill>
@@ -5249,7 +5198,7 @@
               <a:t>{{</a:t>
             </a:r>
             <a:r>
-              <a:rPr lang="en-GB" sz="2400" dirty="0">
+              <a:rPr lang="en-GB" sz="2000" dirty="0">
                 <a:solidFill>
                   <a:srgbClr val="475569"/>
                 </a:solidFill>
@@ -5258,7 +5207,7 @@
               <a:t>TAMIL</a:t>
             </a:r>
             <a:r>
-              <a:rPr lang="en-GB" sz="2400" b="0" i="0" u="none" dirty="0">
+              <a:rPr lang="en-GB" sz="2000" b="0" i="0" u="none" dirty="0">
                 <a:solidFill>
                   <a:srgbClr val="475569"/>
                 </a:solidFill>
@@ -5266,7 +5215,7 @@
               </a:rPr>
               <a:t>}}</a:t>
             </a:r>
-            <a:endParaRPr sz="2400" b="0" i="0" u="none" dirty="0">
+            <a:endParaRPr sz="2000" b="0" i="0" u="none" dirty="0">
               <a:solidFill>
                 <a:srgbClr val="475569"/>
               </a:solidFill>
@@ -5431,6 +5380,57 @@
           <a:p>
             <a:pPr algn="ctr"/>
             <a:endParaRPr lang="en-IN" dirty="0"/>
+          </a:p>
+        </p:txBody>
+      </p:sp>
+      <p:sp>
+        <p:nvSpPr>
+          <p:cNvPr id="8" name="TextBox 7">
+            <a:extLst>
+              <a:ext uri="{FF2B5EF4-FFF2-40B4-BE49-F238E27FC236}">
+                <a16:creationId xmlns:a16="http://schemas.microsoft.com/office/drawing/2014/main" id="{1F5C0FCC-0FD8-8C3C-DB02-254830190C42}"/>
+              </a:ext>
+            </a:extLst>
+          </p:cNvPr>
+          <p:cNvSpPr txBox="1"/>
+          <p:nvPr/>
+        </p:nvSpPr>
+        <p:spPr>
+          <a:xfrm>
+            <a:off x="4572001" y="213702"/>
+            <a:ext cx="7460994" cy="1171475"/>
+          </a:xfrm>
+          <a:prstGeom prst="rect">
+            <a:avLst/>
+          </a:prstGeom>
+          <a:noFill/>
+        </p:spPr>
+        <p:txBody>
+          <a:bodyPr wrap="square" lIns="0" tIns="0" rIns="0" bIns="0" anchor="t">
+            <a:spAutoFit/>
+          </a:bodyPr>
+          <a:lstStyle/>
+          <a:p>
+            <a:pPr algn="ctr">
+              <a:lnSpc>
+                <a:spcPts val="9075"/>
+              </a:lnSpc>
+            </a:pPr>
+            <a:r>
+              <a:rPr lang="en-GB" sz="7400" b="0" i="0" u="none" dirty="0">
+                <a:solidFill>
+                  <a:srgbClr val="0F172A"/>
+                </a:solidFill>
+                <a:latin typeface="Poppins ExtraBold"/>
+              </a:rPr>
+              <a:t>{{WORD}}</a:t>
+            </a:r>
+            <a:endParaRPr sz="7400" b="0" i="0" u="none" dirty="0">
+              <a:solidFill>
+                <a:srgbClr val="0F172A"/>
+              </a:solidFill>
+              <a:latin typeface="Poppins ExtraBold"/>
+            </a:endParaRPr>
           </a:p>
         </p:txBody>
       </p:sp>
@@ -5595,7 +5595,7 @@
         <p:spPr>
           <a:xfrm>
             <a:off x="2630128" y="5984803"/>
-            <a:ext cx="8240048" cy="369332"/>
+            <a:ext cx="8774982" cy="369332"/>
           </a:xfrm>
           <a:prstGeom prst="rect">
             <a:avLst/>
@@ -5897,57 +5897,6 @@
       </p:sp>
       <p:sp>
         <p:nvSpPr>
-          <p:cNvPr id="6" name="TextBox 5">
-            <a:extLst>
-              <a:ext uri="{FF2B5EF4-FFF2-40B4-BE49-F238E27FC236}">
-                <a16:creationId xmlns:a16="http://schemas.microsoft.com/office/drawing/2014/main" id="{304B2B7D-C7F8-A0DE-390F-3455C7396ED4}"/>
-              </a:ext>
-            </a:extLst>
-          </p:cNvPr>
-          <p:cNvSpPr txBox="1"/>
-          <p:nvPr/>
-        </p:nvSpPr>
-        <p:spPr>
-          <a:xfrm>
-            <a:off x="5515897" y="213702"/>
-            <a:ext cx="6517097" cy="1171475"/>
-          </a:xfrm>
-          <a:prstGeom prst="rect">
-            <a:avLst/>
-          </a:prstGeom>
-          <a:noFill/>
-        </p:spPr>
-        <p:txBody>
-          <a:bodyPr wrap="square" lIns="0" tIns="0" rIns="0" bIns="0" anchor="t">
-            <a:spAutoFit/>
-          </a:bodyPr>
-          <a:lstStyle/>
-          <a:p>
-            <a:pPr algn="ctr">
-              <a:lnSpc>
-                <a:spcPts val="9075"/>
-              </a:lnSpc>
-            </a:pPr>
-            <a:r>
-              <a:rPr lang="en-GB" sz="7400" b="0" i="0" u="none" dirty="0">
-                <a:solidFill>
-                  <a:srgbClr val="0F172A"/>
-                </a:solidFill>
-                <a:latin typeface="Poppins ExtraBold"/>
-              </a:rPr>
-              <a:t>{{WORD}}</a:t>
-            </a:r>
-            <a:endParaRPr sz="7400" b="0" i="0" u="none" dirty="0">
-              <a:solidFill>
-                <a:srgbClr val="0F172A"/>
-              </a:solidFill>
-              <a:latin typeface="Poppins ExtraBold"/>
-            </a:endParaRPr>
-          </a:p>
-        </p:txBody>
-      </p:sp>
-      <p:sp>
-        <p:nvSpPr>
           <p:cNvPr id="15" name="TextBox 14">
             <a:extLst>
               <a:ext uri="{FF2B5EF4-FFF2-40B4-BE49-F238E27FC236}">
@@ -6073,7 +6022,7 @@
         <p:spPr>
           <a:xfrm>
             <a:off x="4889704" y="2526335"/>
-            <a:ext cx="3806620" cy="1107996"/>
+            <a:ext cx="3806620" cy="923330"/>
           </a:xfrm>
           <a:prstGeom prst="rect">
             <a:avLst/>
@@ -6088,7 +6037,7 @@
           <a:p>
             <a:pPr algn="ctr"/>
             <a:r>
-              <a:rPr lang="en-GB" sz="2400" b="0" i="0" u="none" dirty="0">
+              <a:rPr lang="en-GB" sz="2000" b="0" i="0" u="none" dirty="0">
                 <a:solidFill>
                   <a:srgbClr val="475569"/>
                 </a:solidFill>
@@ -6097,7 +6046,7 @@
               <a:t>{{</a:t>
             </a:r>
             <a:r>
-              <a:rPr lang="en-GB" sz="2400" dirty="0">
+              <a:rPr lang="en-GB" sz="2000" dirty="0">
                 <a:solidFill>
                   <a:srgbClr val="475569"/>
                 </a:solidFill>
@@ -6106,7 +6055,7 @@
               <a:t>HINDI</a:t>
             </a:r>
             <a:r>
-              <a:rPr lang="en-GB" sz="2400" b="0" i="0" u="none" dirty="0">
+              <a:rPr lang="en-GB" sz="2000" b="0" i="0" u="none" dirty="0">
                 <a:solidFill>
                   <a:srgbClr val="475569"/>
                 </a:solidFill>
@@ -6115,7 +6064,7 @@
               <a:t>}}</a:t>
             </a:r>
             <a:r>
-              <a:rPr sz="2400" b="0" i="0" u="none" dirty="0">
+              <a:rPr sz="2000" b="0" i="0" u="none" dirty="0">
                 <a:solidFill>
                   <a:srgbClr val="475569"/>
                 </a:solidFill>
@@ -6124,12 +6073,12 @@
               <a:t>,</a:t>
             </a:r>
             <a:r>
-              <a:rPr dirty="0"/>
+              <a:rPr sz="2000" dirty="0"/>
               <a:t>
 </a:t>
             </a:r>
             <a:r>
-              <a:rPr sz="2400" b="0" i="0" u="none" dirty="0">
+              <a:rPr sz="2000" b="0" i="0" u="none" dirty="0">
                 <a:solidFill>
                   <a:srgbClr val="475569"/>
                 </a:solidFill>
@@ -6138,7 +6087,7 @@
               <a:t> </a:t>
             </a:r>
             <a:r>
-              <a:rPr lang="en-GB" sz="2400" b="0" i="0" u="none" dirty="0">
+              <a:rPr lang="en-GB" sz="2000" b="0" i="0" u="none" dirty="0">
                 <a:solidFill>
                   <a:srgbClr val="475569"/>
                 </a:solidFill>
@@ -6147,7 +6096,7 @@
               <a:t>{{</a:t>
             </a:r>
             <a:r>
-              <a:rPr lang="en-GB" sz="2400" dirty="0">
+              <a:rPr lang="en-GB" sz="2000" dirty="0">
                 <a:solidFill>
                   <a:srgbClr val="475569"/>
                 </a:solidFill>
@@ -6156,7 +6105,7 @@
               <a:t>MALAYALAM</a:t>
             </a:r>
             <a:r>
-              <a:rPr lang="en-GB" sz="2400" b="0" i="0" u="none" dirty="0">
+              <a:rPr lang="en-GB" sz="2000" b="0" i="0" u="none" dirty="0">
                 <a:solidFill>
                   <a:srgbClr val="475569"/>
                 </a:solidFill>
@@ -6165,7 +6114,7 @@
               <a:t>}}</a:t>
             </a:r>
             <a:r>
-              <a:rPr sz="2400" b="0" i="0" u="none" dirty="0">
+              <a:rPr sz="2000" b="0" i="0" u="none" dirty="0">
                 <a:solidFill>
                   <a:srgbClr val="475569"/>
                 </a:solidFill>
@@ -6174,12 +6123,12 @@
               <a:t>,</a:t>
             </a:r>
             <a:r>
-              <a:rPr dirty="0"/>
+              <a:rPr sz="2000" dirty="0"/>
               <a:t>
 </a:t>
             </a:r>
             <a:r>
-              <a:rPr sz="2400" b="0" i="0" u="none" dirty="0">
+              <a:rPr sz="2000" b="0" i="0" u="none" dirty="0">
                 <a:solidFill>
                   <a:srgbClr val="475569"/>
                 </a:solidFill>
@@ -6188,7 +6137,7 @@
               <a:t> </a:t>
             </a:r>
             <a:r>
-              <a:rPr lang="en-GB" sz="2400" b="0" i="0" u="none" dirty="0">
+              <a:rPr lang="en-GB" sz="2000" b="0" i="0" u="none" dirty="0">
                 <a:solidFill>
                   <a:srgbClr val="475569"/>
                 </a:solidFill>
@@ -6197,7 +6146,7 @@
               <a:t>{{</a:t>
             </a:r>
             <a:r>
-              <a:rPr lang="en-GB" sz="2400" dirty="0">
+              <a:rPr lang="en-GB" sz="2000" dirty="0">
                 <a:solidFill>
                   <a:srgbClr val="475569"/>
                 </a:solidFill>
@@ -6206,7 +6155,7 @@
               <a:t>TAMIL</a:t>
             </a:r>
             <a:r>
-              <a:rPr lang="en-GB" sz="2400" b="0" i="0" u="none" dirty="0">
+              <a:rPr lang="en-GB" sz="2000" b="0" i="0" u="none" dirty="0">
                 <a:solidFill>
                   <a:srgbClr val="475569"/>
                 </a:solidFill>
@@ -6214,7 +6163,7 @@
               </a:rPr>
               <a:t>}}</a:t>
             </a:r>
-            <a:endParaRPr sz="2400" b="0" i="0" u="none" dirty="0">
+            <a:endParaRPr sz="2000" b="0" i="0" u="none" dirty="0">
               <a:solidFill>
                 <a:srgbClr val="475569"/>
               </a:solidFill>
@@ -6379,6 +6328,57 @@
           <a:p>
             <a:pPr algn="ctr"/>
             <a:endParaRPr lang="en-IN" dirty="0"/>
+          </a:p>
+        </p:txBody>
+      </p:sp>
+      <p:sp>
+        <p:nvSpPr>
+          <p:cNvPr id="12" name="TextBox 11">
+            <a:extLst>
+              <a:ext uri="{FF2B5EF4-FFF2-40B4-BE49-F238E27FC236}">
+                <a16:creationId xmlns:a16="http://schemas.microsoft.com/office/drawing/2014/main" id="{82967738-E81B-FB92-320E-5DE7069425EA}"/>
+              </a:ext>
+            </a:extLst>
+          </p:cNvPr>
+          <p:cNvSpPr txBox="1"/>
+          <p:nvPr/>
+        </p:nvSpPr>
+        <p:spPr>
+          <a:xfrm>
+            <a:off x="4572001" y="213702"/>
+            <a:ext cx="7460994" cy="1171475"/>
+          </a:xfrm>
+          <a:prstGeom prst="rect">
+            <a:avLst/>
+          </a:prstGeom>
+          <a:noFill/>
+        </p:spPr>
+        <p:txBody>
+          <a:bodyPr wrap="square" lIns="0" tIns="0" rIns="0" bIns="0" anchor="t">
+            <a:spAutoFit/>
+          </a:bodyPr>
+          <a:lstStyle/>
+          <a:p>
+            <a:pPr algn="ctr">
+              <a:lnSpc>
+                <a:spcPts val="9075"/>
+              </a:lnSpc>
+            </a:pPr>
+            <a:r>
+              <a:rPr lang="en-GB" sz="7400" b="0" i="0" u="none" dirty="0">
+                <a:solidFill>
+                  <a:srgbClr val="0F172A"/>
+                </a:solidFill>
+                <a:latin typeface="Poppins ExtraBold"/>
+              </a:rPr>
+              <a:t>{{WORD}}</a:t>
+            </a:r>
+            <a:endParaRPr sz="7400" b="0" i="0" u="none" dirty="0">
+              <a:solidFill>
+                <a:srgbClr val="0F172A"/>
+              </a:solidFill>
+              <a:latin typeface="Poppins ExtraBold"/>
+            </a:endParaRPr>
           </a:p>
         </p:txBody>
       </p:sp>

</xml_diff>